<commit_message>
Audit and reconcile final OILGUARD results: resolve 19-event cohort, audit early-warning evaluation rules, add LOEO-CV, and verify Pareto frontier
</commit_message>
<xml_diff>
--- a/report/OILGUARD_Presentation.pptx
+++ b/report/OILGUARD_Presentation.pptx
@@ -3194,7 +3194,7 @@
               </a:defRPr>
             </a:pPr>
             <a:r>
-              <a:t>Time Series Analysis (TSA) Applied to Petrobras 3W Real Offshore Data</a:t>
+              <a:t>Time Series Analysis on 19 Real Offshore Well Events (Petrobras 3W)</a:t>
             </a:r>
           </a:p>
           <a:p>
@@ -3207,7 +3207,7 @@
               </a:defRPr>
             </a:pPr>
             <a:r>
-              <a:t>Academic TSA AAT Project Evaluation | Class 2: Spurious Closure of DHSV</a:t>
+              <a:t>Audited Final Results | Class 2: Spurious Closure of DHSV</a:t>
             </a:r>
           </a:p>
         </p:txBody>
@@ -3353,7 +3353,7 @@
                   <a:srgbClr val="3C3C3C"/>
                 </a:solidFill>
               </a:rPr>
-              <a:t>Spurious or uncommanded closure suddenly chokes high-rate production conduits, causing violent pressure hammer surges.</a:t>
+              <a:t>Spurious closure suddenly chokes high-rate production conduits, causing rapid shut-in dynamics.</a:t>
             </a:r>
           </a:p>
           <a:p>
@@ -3393,7 +3393,7 @@
                   <a:srgbClr val="0A3663"/>
                 </a:solidFill>
               </a:rPr>
-              <a:t>Research Hypothesis: </a:t>
+              <a:t>Research Question: </a:t>
             </a:r>
             <a:r>
               <a:rPr>
@@ -3401,7 +3401,7 @@
                   <a:srgbClr val="3C3C3C"/>
                 </a:solidFill>
               </a:rPr>
-              <a:t>Can statistical forecasting residuals (e_t = y_t - y_hat_t) detect subtle pre-transient pressure anomalies 5-10 minutes in advance?</a:t>
+              <a:t>Can statistical forecasting residuals (e_t = y_t - y_hat_t) provide reliable early warnings 5-10 minutes in advance?</a:t>
             </a:r>
           </a:p>
           <a:p>
@@ -3417,7 +3417,7 @@
                   <a:srgbClr val="0A3663"/>
                 </a:solidFill>
               </a:rPr>
-              <a:t>Baseline Benchmark: </a:t>
+              <a:t>Baseline Comparator: </a:t>
             </a:r>
             <a:r>
               <a:rPr>
@@ -3425,7 +3425,7 @@
                   <a:srgbClr val="3C3C3C"/>
                 </a:solidFill>
               </a:rPr>
-              <a:t>A persistent Naive baseline (y_hat_t = y_{t-1}) is tested alongside ARIMA and SARIMAX.</a:t>
+              <a:t>A persistent Naive baseline (y_hat_t = y_{t-1}) is benchmarked against ARIMA and SARIMAX.</a:t>
             </a:r>
           </a:p>
         </p:txBody>
@@ -3563,7 +3563,7 @@
                   <a:srgbClr val="0A3663"/>
                 </a:solidFill>
               </a:rPr>
-              <a:t>Strict Real-Well Filtering: </a:t>
+              <a:t>Strict Gold Cohort (N=19): </a:t>
             </a:r>
             <a:r>
               <a:rPr>
@@ -3571,7 +3571,7 @@
                   <a:srgbClr val="3C3C3C"/>
                 </a:solidFill>
               </a:rPr>
-              <a:t>Excluded all simulated instances to ensure authentic physics; filtered exclusively for real well recordings (WELL-*).</a:t>
+              <a:t>Audited 22 real-well Class 2 candidates; 19 gold events accepted. Excluded 3 files (including 1 constant flatline sensor file).</a:t>
             </a:r>
           </a:p>
           <a:p>
@@ -3595,7 +3595,7 @@
                   <a:srgbClr val="3C3C3C"/>
                 </a:solidFill>
               </a:rPr>
-              <a:t>Target sensor: P-TPT (downhole pressure transducer, MPa); Exogenous sensor: T-TPT (downhole temperature, degC).</a:t>
+              <a:t>Target: P-TPT (downhole pressure, MPa); Exogenous: T-TPT (downhole temperature, degC).</a:t>
             </a:r>
           </a:p>
           <a:p>
@@ -3635,7 +3635,7 @@
                   <a:srgbClr val="0A3663"/>
                 </a:solidFill>
               </a:rPr>
-              <a:t>Strict Sequential Partitioning: </a:t>
+              <a:t>Strict Chronological Partitioning: </a:t>
             </a:r>
             <a:r>
               <a:rPr>
@@ -3643,7 +3643,7 @@
                   <a:srgbClr val="3C3C3C"/>
                 </a:solidFill>
               </a:rPr>
-              <a:t>60% Training (model fitting) | 20% Calibration (threshold quantile calibration) | 20% Holdout + Full Transient (evaluation).</a:t>
+              <a:t>60% Training (model fitting) | 20% Calibration (threshold calibration) | 20% Holdout + Full Transient (evaluation).</a:t>
             </a:r>
           </a:p>
         </p:txBody>
@@ -3853,7 +3853,7 @@
                   <a:srgbClr val="0A3663"/>
                 </a:solidFill>
               </a:rPr>
-              <a:t>Key Conclusion: </a:t>
+              <a:t>Key Finding: </a:t>
             </a:r>
             <a:r>
               <a:rPr>
@@ -3959,7 +3959,7 @@
               </a:defRPr>
             </a:pPr>
             <a:r>
-              <a:t>Diagnosis: The Noisy Baseline Paradox</a:t>
+              <a:t>Audit of Early-Warning Evaluation Rules</a:t>
             </a:r>
           </a:p>
           <a:p>
@@ -3975,7 +3975,7 @@
                   <a:srgbClr val="0A3663"/>
                 </a:solidFill>
               </a:rPr>
-              <a:t>The Apparent Anomaly: </a:t>
+              <a:t>The Anomaly in Default Rules: </a:t>
             </a:r>
             <a:r>
               <a:rPr>
@@ -3983,7 +3983,7 @@
                   <a:srgbClr val="3C3C3C"/>
                 </a:solidFill>
               </a:rPr>
-              <a:t>Under initial default settings (q=0.99, p=3), Naive reported 47.4% transient early detection vs. 42.1% for ARIMA.</a:t>
+              <a:t>Under unoptimized static settings (q=0.99, p=3), Naive reported 7/19 early detections vs. 5/19 for ARIMA.</a:t>
             </a:r>
           </a:p>
           <a:p>
@@ -3999,7 +3999,7 @@
                   <a:srgbClr val="0A3663"/>
                 </a:solidFill>
               </a:rPr>
-              <a:t>Forensic Investigation: </a:t>
+              <a:t>Audited Window Policy: </a:t>
             </a:r>
             <a:r>
               <a:rPr>
@@ -4007,7 +4007,7 @@
                   <a:srgbClr val="3C3C3C"/>
                 </a:solidFill>
               </a:rPr>
-              <a:t>On event WELL-00011_20141006150121, Naive fired an alarm during normal operation due to high forecast variance.</a:t>
+              <a:t>Early warnings must strictly occur inside the 10-minute pre-event window [t_transient - 10m, t_transient).</a:t>
             </a:r>
           </a:p>
           <a:p>
@@ -4023,7 +4023,7 @@
                   <a:srgbClr val="0A3663"/>
                 </a:solidFill>
               </a:rPr>
-              <a:t>The False Alarm Flaw: </a:t>
+              <a:t>False Alarm Separation: </a:t>
             </a:r>
             <a:r>
               <a:rPr>
@@ -4031,7 +4031,7 @@
                   <a:srgbClr val="3C3C3C"/>
                 </a:solidFill>
               </a:rPr>
-              <a:t>Because this spurious alarm occurred 1.17 min before transient onset, it was naively credited as an early detection!</a:t>
+              <a:t>Alarms occurring during ordinary normal operation (before the pre-event window) are counted strictly as false alarms.</a:t>
             </a:r>
           </a:p>
           <a:p>
@@ -4047,7 +4047,7 @@
                   <a:srgbClr val="0A3663"/>
                 </a:solidFill>
               </a:rPr>
-              <a:t>False Alarm Rates: </a:t>
+              <a:t>Lead Time Integrity: </a:t>
             </a:r>
             <a:r>
               <a:rPr>
@@ -4055,7 +4055,7 @@
                   <a:srgbClr val="3C3C3C"/>
                 </a:solidFill>
               </a:rPr>
-              <a:t>Naive suffered 7 total false alarms with lower precision (68.5%), whereas ARIMA had 0 adjusted false alarms.</a:t>
+              <a:t>Lead times are calculated strictly from the pre-event alarm, guaranteeing bounded lead times (0 &lt;= lead &lt;= 10 min).</a:t>
             </a:r>
           </a:p>
           <a:p>
@@ -4071,7 +4071,7 @@
                   <a:srgbClr val="0A3663"/>
                 </a:solidFill>
               </a:rPr>
-              <a:t>The Fix Required: </a:t>
+              <a:t>Denominator Integrity: </a:t>
             </a:r>
             <a:r>
               <a:rPr>
@@ -4079,7 +4079,7 @@
                   <a:srgbClr val="3C3C3C"/>
                 </a:solidFill>
               </a:rPr>
-              <a:t>Systematic optimization of threshold selection and residual integration to unlock ARIMAs true predictive power.</a:t>
+              <a:t>All metrics use exactly the 19 evaluated gold events as the denominator.</a:t>
             </a:r>
           </a:p>
         </p:txBody>
@@ -4177,7 +4177,7 @@
               </a:defRPr>
             </a:pPr>
             <a:r>
-              <a:t>Optimization 1: Multi-Parameter Pareto Grid Search</a:t>
+              <a:t>Unbiased Generalization: Leave-One-Event-Out Cross-Validation</a:t>
             </a:r>
           </a:p>
           <a:p>
@@ -4193,7 +4193,7 @@
                   <a:srgbClr val="0A3663"/>
                 </a:solidFill>
               </a:rPr>
-              <a:t>Grid Exploration: </a:t>
+              <a:t>Preventing Data Leakage: </a:t>
             </a:r>
             <a:r>
               <a:rPr>
@@ -4201,7 +4201,7 @@
                   <a:srgbClr val="3C3C3C"/>
                 </a:solidFill>
               </a:rPr>
-              <a:t>Evaluated quantiles [0.90 to 0.995] across persistence filters [1 to 5] on the 20-event cohort.</a:t>
+              <a:t>Retrospective grid search on holdout sets causes leakage. To guarantee unbiased evaluation, LOEO-CV was executed.</a:t>
             </a:r>
           </a:p>
           <a:p>
@@ -4217,7 +4217,7 @@
                   <a:srgbClr val="0A3663"/>
                 </a:solidFill>
               </a:rPr>
-              <a:t>Optimal Operating Point (p=1, q=0.95): </a:t>
+              <a:t>ARIMA LOEO-CV Detection: </a:t>
             </a:r>
             <a:r>
               <a:rPr>
@@ -4225,7 +4225,7 @@
                   <a:srgbClr val="3C3C3C"/>
                 </a:solidFill>
               </a:rPr>
-              <a:t>ARIMA achieves 85.0% early detection rate (17/20 events) with 7.71 minutes mean lead time!</a:t>
+              <a:t>ARIMA achieves 42.1% early detection (8/19 events) with 5.10 minutes advance lead time.</a:t>
             </a:r>
           </a:p>
           <a:p>
@@ -4241,7 +4241,7 @@
                   <a:srgbClr val="0A3663"/>
                 </a:solidFill>
               </a:rPr>
-              <a:t>SARIMAX Operating Point: </a:t>
+              <a:t>Naive Baseline LOEO-CV: </a:t>
             </a:r>
             <a:r>
               <a:rPr>
@@ -4249,7 +4249,7 @@
                   <a:srgbClr val="3C3C3C"/>
                 </a:solidFill>
               </a:rPr>
-              <a:t>SARIMAX achieves 85.0% early detection with 7.97 minutes mean lead time!</a:t>
+              <a:t>Naive baseline achieves 36.8% early detection (7/19 events) with 1.69 minutes lead time.</a:t>
             </a:r>
           </a:p>
           <a:p>
@@ -4265,7 +4265,7 @@
                   <a:srgbClr val="0A3663"/>
                 </a:solidFill>
               </a:rPr>
-              <a:t>Decisive Baseline Margin: </a:t>
+              <a:t>The Lead Time Advantage: </a:t>
             </a:r>
             <a:r>
               <a:rPr>
@@ -4273,7 +4273,7 @@
                   <a:srgbClr val="3C3C3C"/>
                 </a:solidFill>
               </a:rPr>
-              <a:t>Naive baseline achieves only 70.0% under the same configuration -&gt; TSA models provide +15.0% advantage!</a:t>
+              <a:t>ARIMA delivers over 3x the advance warning lead time of the baseline (5.10 min vs. 1.69 min)!</a:t>
             </a:r>
           </a:p>
           <a:p>
@@ -4289,7 +4289,7 @@
                   <a:srgbClr val="0A3663"/>
                 </a:solidFill>
               </a:rPr>
-              <a:t>Pareto Superiority: </a:t>
+              <a:t>Conclusion: </a:t>
             </a:r>
             <a:r>
               <a:rPr>
@@ -4297,7 +4297,7 @@
                   <a:srgbClr val="3C3C3C"/>
                 </a:solidFill>
               </a:rPr>
-              <a:t>ARIMA dominates the Pareto frontier, delivering higher detection rates at equivalent false alarm frequencies.</a:t>
+              <a:t>In honest cross-validation, statistical TSA models outperform the baseline in both detection rate and reaction window.</a:t>
             </a:r>
           </a:p>
         </p:txBody>
@@ -4395,7 +4395,7 @@
               </a:defRPr>
             </a:pPr>
             <a:r>
-              <a:t>Optimization 2: EWMA Filtered Residual Anomaly Detection</a:t>
+              <a:t>Sensitivity Analysis &amp; EWMA Residual Filtering</a:t>
             </a:r>
           </a:p>
           <a:p>
@@ -4411,7 +4411,7 @@
                   <a:srgbClr val="0A3663"/>
                 </a:solidFill>
               </a:rPr>
-              <a:t>The Concept: </a:t>
+              <a:t>Grid Sensitivity Ceiling (p=1, q=0.95): </a:t>
             </a:r>
             <a:r>
               <a:rPr>
@@ -4419,7 +4419,7 @@
                   <a:srgbClr val="3C3C3C"/>
                 </a:solidFill>
               </a:rPr>
-              <a:t>Replace raw instantaneous residual checking with Exponentially Weighted Moving Average (EWMA): S_t = lambda|e_t| + (1-lambda)S_{t-1}.</a:t>
+              <a:t>ARIMA achieves 63.2% early detection (12/19) with 5.35 min lead time (empirical upper bound under post-hoc selection).</a:t>
             </a:r>
           </a:p>
           <a:p>
@@ -4435,7 +4435,7 @@
                   <a:srgbClr val="0A3663"/>
                 </a:solidFill>
               </a:rPr>
-              <a:t>Noise Attenuation: </a:t>
+              <a:t>EWMA Filtered Residuals (lambda=0.3, q=0.975): </a:t>
             </a:r>
             <a:r>
               <a:rPr>
@@ -4443,7 +4443,7 @@
                   <a:srgbClr val="3C3C3C"/>
                 </a:solidFill>
               </a:rPr>
-              <a:t>Filters out spurious single-sample sensor spikes while integrating persistent drift from incipient valve closure.</a:t>
+              <a:t>ARIMA achieves 57.9% early warning (11/19) with 3.53 min lead time at 1.72 FA/hr.</a:t>
             </a:r>
           </a:p>
           <a:p>
@@ -4459,7 +4459,7 @@
                   <a:srgbClr val="0A3663"/>
                 </a:solidFill>
               </a:rPr>
-              <a:t>Performance at lambda=0.5, q=0.975: </a:t>
+              <a:t>Naive Comparison under EWMA: </a:t>
             </a:r>
             <a:r>
               <a:rPr>
@@ -4467,7 +4467,7 @@
                   <a:srgbClr val="3C3C3C"/>
                 </a:solidFill>
               </a:rPr>
-              <a:t>ARIMA &amp; SARIMAX achieve 80.0% early detection rate with 7.73 minutes of lead time!</a:t>
+              <a:t>Naive achieves 42.1% (8/19) -&gt; ARIMA provides a +15.8% advantage at identical false alarm rate.</a:t>
             </a:r>
           </a:p>
           <a:p>
@@ -4483,7 +4483,7 @@
                   <a:srgbClr val="0A3663"/>
                 </a:solidFill>
               </a:rPr>
-              <a:t>Massive Baseline Separation: </a:t>
+              <a:t>Noise Attenuation: </a:t>
             </a:r>
             <a:r>
               <a:rPr>
@@ -4491,7 +4491,7 @@
                   <a:srgbClr val="3C3C3C"/>
                 </a:solidFill>
               </a:rPr>
-              <a:t>Naive baseline achieves only 60.0% detection with 5.69 min lead time -&gt; TSA models deliver a +20.0% gain!</a:t>
+              <a:t>EWMA integrates persistent incipient drift while attenuating high-frequency turbulent sensor noise.</a:t>
             </a:r>
           </a:p>
           <a:p>
@@ -4507,7 +4507,7 @@
                   <a:srgbClr val="0A3663"/>
                 </a:solidFill>
               </a:rPr>
-              <a:t>Industrial Alignment: </a:t>
+              <a:t>Pareto Frontier Verification: </a:t>
             </a:r>
             <a:r>
               <a:rPr>
@@ -4515,7 +4515,7 @@
                   <a:srgbClr val="3C3C3C"/>
                 </a:solidFill>
               </a:rPr>
-              <a:t>Matches gold-standard Statistical Process Control (SPC) used in petroleum refineries.</a:t>
+              <a:t>Non-dominated Pareto points programmatically calculated and verified on the 19 gold events.</a:t>
             </a:r>
           </a:p>
         </p:txBody>
@@ -4613,7 +4613,7 @@
               </a:defRPr>
             </a:pPr>
             <a:r>
-              <a:t>Operational Value &amp; Recommendations</a:t>
+              <a:t>Operational Value &amp; Qualified Conclusions</a:t>
             </a:r>
           </a:p>
           <a:p>
@@ -4629,7 +4629,7 @@
                   <a:srgbClr val="0A3663"/>
                 </a:solidFill>
               </a:rPr>
-              <a:t>Actionable Early Warning: </a:t>
+              <a:t>Actionable Lead Time: </a:t>
             </a:r>
             <a:r>
               <a:rPr>
@@ -4637,7 +4637,7 @@
                   <a:srgbClr val="3C3C3C"/>
                 </a:solidFill>
               </a:rPr>
-              <a:t>8 minutes of advance lead time allows platform control systems to execute controlled well chokes.</a:t>
+              <a:t>5 minutes of advance lead time provides platform operators a potential window for diagnostic assessment and manual choke throttling.</a:t>
             </a:r>
           </a:p>
           <a:p>
@@ -4653,7 +4653,7 @@
                   <a:srgbClr val="0A3663"/>
                 </a:solidFill>
               </a:rPr>
-              <a:t>Mitigating Catastrophic Surges: </a:t>
+              <a:t>Qualified Engineering Scope: </a:t>
             </a:r>
             <a:r>
               <a:rPr>
@@ -4661,7 +4661,7 @@
                   <a:srgbClr val="3C3C3C"/>
                 </a:solidFill>
               </a:rPr>
-              <a:t>Prevents severe water hammer effects that damage subsea manifolds and trip safety separators.</a:t>
+              <a:t>Whether early warnings can reliably prevent water-hammer shocks or valve damage remains an engineering hypothesis requiring multiphase dynamic simulation (OLGA).</a:t>
             </a:r>
           </a:p>
           <a:p>
@@ -4677,7 +4677,7 @@
                   <a:srgbClr val="0A3663"/>
                 </a:solidFill>
               </a:rPr>
-              <a:t>Reproducible Pipeline: </a:t>
+              <a:t>Reproducible Architecture: </a:t>
             </a:r>
             <a:r>
               <a:rPr>
@@ -4685,7 +4685,7 @@
                   <a:srgbClr val="3C3C3C"/>
                 </a:solidFill>
               </a:rPr>
-              <a:t>Automated Python architecture complete with unit tests, parameter config, and Jupyter walkthrough.</a:t>
+              <a:t>End-to-end Python pipeline complete with 10 unit tests, parameter config, and Jupyter walkthrough.</a:t>
             </a:r>
           </a:p>
           <a:p>
@@ -4709,7 +4709,7 @@
                   <a:srgbClr val="3C3C3C"/>
                 </a:solidFill>
               </a:rPr>
-              <a:t>Statistical time series analysis delivers 47% better forecasting and +15% to +20% superior early warning accuracy over baseline methods.</a:t>
+              <a:t>Statistical time series analysis delivers 47% better forecasting and superior advance warning lead time over persistence baselines.</a:t>
             </a:r>
           </a:p>
         </p:txBody>

</xml_diff>

<commit_message>
Implement OILGUARD-AC: literature review, research gap, multisensor residual scoring, alarm-budgeted threshold calibration, and LOEO-CV benchmarks
</commit_message>
<xml_diff>
--- a/report/OILGUARD_Presentation.pptx
+++ b/report/OILGUARD_Presentation.pptx
@@ -3097,7 +3097,7 @@
       <p:grpSpPr/>
       <p:sp>
         <p:nvSpPr>
-          <p:cNvPr id="2" name="Rounded Rectangle 1"/>
+          <p:cNvPr id="2" name="Rectangle 1"/>
           <p:cNvSpPr/>
           <p:nvPr/>
         </p:nvSpPr>
@@ -3106,16 +3106,14 @@
             <a:off x="0" y="0"/>
             <a:ext cx="12191695" cy="6858000"/>
           </a:xfrm>
-          <a:prstGeom prst="roundRect">
+          <a:prstGeom prst="rect">
             <a:avLst/>
           </a:prstGeom>
           <a:solidFill>
-            <a:srgbClr val="0A3663"/>
+            <a:srgbClr val="0A2540"/>
           </a:solidFill>
           <a:ln>
-            <a:solidFill>
-              <a:srgbClr val="0A3663"/>
-            </a:solidFill>
+            <a:noFill/>
           </a:ln>
         </p:spPr>
         <p:style>
@@ -3163,51 +3161,43 @@
           <a:lstStyle/>
           <a:p>
             <a:pPr>
-              <a:defRPr sz="4800" b="1">
-                <a:solidFill>
-                  <a:srgbClr val="FFFFFF"/>
+              <a:defRPr sz="4200" b="1">
+                <a:solidFill>
+                  <a:srgbClr val="6BAED6"/>
                 </a:solidFill>
               </a:defRPr>
             </a:pPr>
             <a:r>
-              <a:t>OILGUARD</a:t>
+              <a:t>OILGUARD-AC</a:t>
             </a:r>
           </a:p>
           <a:p>
             <a:pPr>
-              <a:defRPr sz="2400" b="1">
-                <a:solidFill>
-                  <a:srgbClr val="D4AF37"/>
+              <a:defRPr sz="2200">
+                <a:solidFill>
+                  <a:srgbClr val="FFFFFF"/>
                 </a:solidFill>
               </a:defRPr>
             </a:pPr>
             <a:r>
-              <a:t>Forecasting-Based Early Warning of Abnormal Events in Oil Wells</a:t>
-            </a:r>
-          </a:p>
-          <a:p>
+              <a:t>Alarm-Constrained, Multisensor Early Warning for Spurious DHSV Closure in Offshore Oil Wells</a:t>
+            </a:r>
+          </a:p>
+          <a:p>
+            <a:br/>
             <a:pPr>
-              <a:defRPr sz="1600">
-                <a:solidFill>
-                  <a:srgbClr val="C8DCF0"/>
+              <a:defRPr sz="1400">
+                <a:solidFill>
+                  <a:srgbClr val="BDC3C7"/>
                 </a:solidFill>
               </a:defRPr>
             </a:pPr>
             <a:r>
-              <a:t>Time Series Analysis on 19 Real Offshore Well Events (Petrobras 3W)</a:t>
-            </a:r>
-          </a:p>
-          <a:p>
+              <a:t>Time Series Analysis Applied to the Petrobras 3W Benchmark Dataset</a:t>
+            </a:r>
             <a:br/>
-            <a:pPr>
-              <a:defRPr sz="1300">
-                <a:solidFill>
-                  <a:srgbClr val="A0BEDC"/>
-                </a:solidFill>
-              </a:defRPr>
-            </a:pPr>
-            <a:r>
-              <a:t>Audited Final Results | Class 2: Spurious Closure of DHSV</a:t>
+            <a:r>
+              <a:t>Antigravity Research Team | October 2026</a:t>
             </a:r>
           </a:p>
         </p:txBody>
@@ -3232,59 +3222,14 @@
       <p:grpSpPr/>
       <p:sp>
         <p:nvSpPr>
-          <p:cNvPr id="2" name="Rounded Rectangle 1"/>
-          <p:cNvSpPr/>
+          <p:cNvPr id="2" name="TextBox 1"/>
+          <p:cNvSpPr txBox="1"/>
           <p:nvPr/>
         </p:nvSpPr>
         <p:spPr>
           <a:xfrm>
-            <a:off x="731520" y="548640"/>
-            <a:ext cx="10728655" cy="5760720"/>
-          </a:xfrm>
-          <a:prstGeom prst="roundRect">
-            <a:avLst/>
-          </a:prstGeom>
-          <a:solidFill>
-            <a:srgbClr val="F8FAFC"/>
-          </a:solidFill>
-          <a:ln>
-            <a:solidFill>
-              <a:srgbClr val="F8FAFC"/>
-            </a:solidFill>
-          </a:ln>
-        </p:spPr>
-        <p:style>
-          <a:lnRef idx="1">
-            <a:schemeClr val="accent1"/>
-          </a:lnRef>
-          <a:fillRef idx="3">
-            <a:schemeClr val="accent1"/>
-          </a:fillRef>
-          <a:effectRef idx="2">
-            <a:schemeClr val="accent1"/>
-          </a:effectRef>
-          <a:fontRef idx="minor">
-            <a:schemeClr val="lt1"/>
-          </a:fontRef>
-        </p:style>
-        <p:txBody>
-          <a:bodyPr rtlCol="0" anchor="ctr"/>
-          <a:lstStyle/>
-          <a:p>
-            <a:pPr algn="ctr"/>
-          </a:p>
-        </p:txBody>
-      </p:sp>
-      <p:sp>
-        <p:nvSpPr>
-          <p:cNvPr id="3" name="TextBox 2"/>
-          <p:cNvSpPr txBox="1"/>
-          <p:nvPr/>
-        </p:nvSpPr>
-        <p:spPr>
-          <a:xfrm>
-            <a:off x="1097280" y="822960"/>
-            <a:ext cx="10058400" cy="5120640"/>
+            <a:off x="731520" y="365760"/>
+            <a:ext cx="10698480" cy="914400"/>
           </a:xfrm>
           <a:prstGeom prst="rect">
             <a:avLst/>
@@ -3298,134 +3243,115 @@
           <a:lstStyle/>
           <a:p>
             <a:pPr>
-              <a:defRPr sz="2600" b="1">
-                <a:solidFill>
-                  <a:srgbClr val="0A3663"/>
+              <a:defRPr sz="1000" b="1">
+                <a:solidFill>
+                  <a:srgbClr val="2B5C8F"/>
                 </a:solidFill>
               </a:defRPr>
             </a:pPr>
             <a:r>
-              <a:t>The Industrial Challenge: Spurious DHSV Closure</a:t>
+              <a:t>PHYSICAL CONTEXT</a:t>
             </a:r>
           </a:p>
           <a:p>
             <a:pPr>
-              <a:spcBef>
-                <a:spcPts val="1000"/>
-              </a:spcBef>
-              <a:defRPr sz="1500"/>
+              <a:defRPr sz="2200" b="1">
+                <a:solidFill>
+                  <a:srgbClr val="0A3663"/>
+                </a:solidFill>
+              </a:defRPr>
             </a:pPr>
             <a:r>
-              <a:rPr b="1">
+              <a:t>Operational Problem: Spurious Closure of Downhole Safety Valve</a:t>
+            </a:r>
+          </a:p>
+        </p:txBody>
+      </p:sp>
+      <p:sp>
+        <p:nvSpPr>
+          <p:cNvPr id="3" name="TextBox 2"/>
+          <p:cNvSpPr txBox="1"/>
+          <p:nvPr/>
+        </p:nvSpPr>
+        <p:spPr>
+          <a:xfrm>
+            <a:off x="731520" y="1371600"/>
+            <a:ext cx="10698480" cy="4754880"/>
+          </a:xfrm>
+          <a:prstGeom prst="rect">
+            <a:avLst/>
+          </a:prstGeom>
+          <a:noFill/>
+        </p:spPr>
+        <p:txBody>
+          <a:bodyPr wrap="square">
+            <a:spAutoFit/>
+          </a:bodyPr>
+          <a:lstStyle/>
+          <a:p>
+            <a:r>
+              <a:rPr sz="1500" b="1">
                 <a:solidFill>
                   <a:srgbClr val="0A3663"/>
                 </a:solidFill>
               </a:rPr>
-              <a:t>Subsea Safety Valve Criticality: </a:t>
-            </a:r>
-            <a:r>
-              <a:rPr>
-                <a:solidFill>
-                  <a:srgbClr val="3C3C3C"/>
+              <a:t>The Downhole Safety Valve (DHSV): </a:t>
+            </a:r>
+            <a:r>
+              <a:rPr sz="1500" b="0"/>
+              <a:t>Subsea emergency barrier installed hundreds of meters below mudline.
+</a:t>
+            </a:r>
+            <a:r>
+              <a:rPr sz="1500" b="1">
+                <a:solidFill>
+                  <a:srgbClr val="0A3663"/>
                 </a:solidFill>
               </a:rPr>
-              <a:t>Downhole Safety Valves (DHSV) protect offshore platforms against uncontrolled well blowouts.</a:t>
-            </a:r>
-          </a:p>
-          <a:p>
-            <a:pPr>
-              <a:spcBef>
-                <a:spcPts val="1000"/>
-              </a:spcBef>
-              <a:defRPr sz="1500"/>
-            </a:pPr>
-            <a:r>
-              <a:rPr b="1">
+              <a:t>The Spurious Closure Event (Class 2): </a:t>
+            </a:r>
+            <a:r>
+              <a:rPr sz="1500" b="0"/>
+              <a:t>Inadvertent flapper closure cuts flowing hydrocarbons, trapping extreme reservoir pressure upstream while downstream pressure collapses.
+</a:t>
+            </a:r>
+            <a:r>
+              <a:rPr sz="1500" b="1">
                 <a:solidFill>
                   <a:srgbClr val="0A3663"/>
                 </a:solidFill>
               </a:rPr>
-              <a:t>The Failure Mode (Class 2): </a:t>
-            </a:r>
-            <a:r>
-              <a:rPr>
-                <a:solidFill>
-                  <a:srgbClr val="3C3C3C"/>
+              <a:t>Fatal Limitation of Static SCADA Alarms: </a:t>
+            </a:r>
+            <a:r>
+              <a:rPr sz="1500" b="0"/>
+              <a:t>Conventional threshold trips (P &lt; P_trip) trigger only after the valve is fully seated. Zero reaction time for mitigation.
+</a:t>
+            </a:r>
+            <a:r>
+              <a:rPr sz="1500" b="1">
+                <a:solidFill>
+                  <a:srgbClr val="0A3663"/>
                 </a:solidFill>
               </a:rPr>
-              <a:t>Spurious closure suddenly chokes high-rate production conduits, causing rapid shut-in dynamics.</a:t>
-            </a:r>
-          </a:p>
-          <a:p>
-            <a:pPr>
-              <a:spcBef>
-                <a:spcPts val="1000"/>
-              </a:spcBef>
-              <a:defRPr sz="1500"/>
-            </a:pPr>
-            <a:r>
-              <a:rPr b="1">
+              <a:t>The Operational Window Hypothesis: </a:t>
+            </a:r>
+            <a:r>
+              <a:rPr sz="1500" b="0"/>
+              <a:t>Detecting incipient pressure deviations 4-6 minutes prior to transient onset provides an opportunity for supervisory choke throttling to decelerate fluid velocity.
+</a:t>
+            </a:r>
+            <a:r>
+              <a:rPr sz="1500" b="1">
                 <a:solidFill>
                   <a:srgbClr val="0A3663"/>
                 </a:solidFill>
               </a:rPr>
-              <a:t>Limitations of Threshold Alarms: </a:t>
-            </a:r>
-            <a:r>
-              <a:rPr>
-                <a:solidFill>
-                  <a:srgbClr val="3C3C3C"/>
-                </a:solidFill>
-              </a:rPr>
-              <a:t>Current alarms only trigger when pressure crosses fixed lower limits—after the shut-in transient has already peaked.</a:t>
-            </a:r>
-          </a:p>
-          <a:p>
-            <a:pPr>
-              <a:spcBef>
-                <a:spcPts val="1000"/>
-              </a:spcBef>
-              <a:defRPr sz="1500"/>
-            </a:pPr>
-            <a:r>
-              <a:rPr b="1">
-                <a:solidFill>
-                  <a:srgbClr val="0A3663"/>
-                </a:solidFill>
-              </a:rPr>
-              <a:t>Research Question: </a:t>
-            </a:r>
-            <a:r>
-              <a:rPr>
-                <a:solidFill>
-                  <a:srgbClr val="3C3C3C"/>
-                </a:solidFill>
-              </a:rPr>
-              <a:t>Can statistical forecasting residuals (e_t = y_t - y_hat_t) provide reliable early warnings 5-10 minutes in advance?</a:t>
-            </a:r>
-          </a:p>
-          <a:p>
-            <a:pPr>
-              <a:spcBef>
-                <a:spcPts val="1000"/>
-              </a:spcBef>
-              <a:defRPr sz="1500"/>
-            </a:pPr>
-            <a:r>
-              <a:rPr b="1">
-                <a:solidFill>
-                  <a:srgbClr val="0A3663"/>
-                </a:solidFill>
-              </a:rPr>
-              <a:t>Baseline Comparator: </a:t>
-            </a:r>
-            <a:r>
-              <a:rPr>
-                <a:solidFill>
-                  <a:srgbClr val="3C3C3C"/>
-                </a:solidFill>
-              </a:rPr>
-              <a:t>A persistent Naive baseline (y_hat_t = y_{t-1}) is benchmarked against ARIMA and SARIMAX.</a:t>
+              <a:t>Physical Reality &amp; Engineering Scope: </a:t>
+            </a:r>
+            <a:r>
+              <a:rPr sz="1500" b="0"/>
+              <a:t>Surge attenuation and water-hammer mitigation are engineering hypotheses that require transient multiphase simulation (OLGA) before field deployment.</a:t>
             </a:r>
           </a:p>
         </p:txBody>
@@ -3450,59 +3376,14 @@
       <p:grpSpPr/>
       <p:sp>
         <p:nvSpPr>
-          <p:cNvPr id="2" name="Rounded Rectangle 1"/>
-          <p:cNvSpPr/>
+          <p:cNvPr id="2" name="TextBox 1"/>
+          <p:cNvSpPr txBox="1"/>
           <p:nvPr/>
         </p:nvSpPr>
         <p:spPr>
           <a:xfrm>
-            <a:off x="731520" y="548640"/>
-            <a:ext cx="10728655" cy="5760720"/>
-          </a:xfrm>
-          <a:prstGeom prst="roundRect">
-            <a:avLst/>
-          </a:prstGeom>
-          <a:solidFill>
-            <a:srgbClr val="F8FAFC"/>
-          </a:solidFill>
-          <a:ln>
-            <a:solidFill>
-              <a:srgbClr val="F8FAFC"/>
-            </a:solidFill>
-          </a:ln>
-        </p:spPr>
-        <p:style>
-          <a:lnRef idx="1">
-            <a:schemeClr val="accent1"/>
-          </a:lnRef>
-          <a:fillRef idx="3">
-            <a:schemeClr val="accent1"/>
-          </a:fillRef>
-          <a:effectRef idx="2">
-            <a:schemeClr val="accent1"/>
-          </a:effectRef>
-          <a:fontRef idx="minor">
-            <a:schemeClr val="lt1"/>
-          </a:fontRef>
-        </p:style>
-        <p:txBody>
-          <a:bodyPr rtlCol="0" anchor="ctr"/>
-          <a:lstStyle/>
-          <a:p>
-            <a:pPr algn="ctr"/>
-          </a:p>
-        </p:txBody>
-      </p:sp>
-      <p:sp>
-        <p:nvSpPr>
-          <p:cNvPr id="3" name="TextBox 2"/>
-          <p:cNvSpPr txBox="1"/>
-          <p:nvPr/>
-        </p:nvSpPr>
-        <p:spPr>
-          <a:xfrm>
-            <a:off x="1097280" y="822960"/>
-            <a:ext cx="10058400" cy="5120640"/>
+            <a:off x="731520" y="365760"/>
+            <a:ext cx="10698480" cy="914400"/>
           </a:xfrm>
           <a:prstGeom prst="rect">
             <a:avLst/>
@@ -3516,134 +3397,102 @@
           <a:lstStyle/>
           <a:p>
             <a:pPr>
-              <a:defRPr sz="2600" b="1">
-                <a:solidFill>
-                  <a:srgbClr val="0A3663"/>
+              <a:defRPr sz="1000" b="1">
+                <a:solidFill>
+                  <a:srgbClr val="2B5C8F"/>
                 </a:solidFill>
               </a:defRPr>
             </a:pPr>
             <a:r>
-              <a:t>Dataset Auditing &amp; Preprocessing Integrity</a:t>
+              <a:t>STATE OF THE ART</a:t>
             </a:r>
           </a:p>
           <a:p>
             <a:pPr>
-              <a:spcBef>
-                <a:spcPts val="1000"/>
-              </a:spcBef>
-              <a:defRPr sz="1500"/>
+              <a:defRPr sz="2200" b="1">
+                <a:solidFill>
+                  <a:srgbClr val="0A3663"/>
+                </a:solidFill>
+              </a:defRPr>
             </a:pPr>
             <a:r>
-              <a:rPr b="1">
+              <a:t>Literature Review &amp; Identified Research Gap</a:t>
+            </a:r>
+          </a:p>
+        </p:txBody>
+      </p:sp>
+      <p:sp>
+        <p:nvSpPr>
+          <p:cNvPr id="3" name="TextBox 2"/>
+          <p:cNvSpPr txBox="1"/>
+          <p:nvPr/>
+        </p:nvSpPr>
+        <p:spPr>
+          <a:xfrm>
+            <a:off x="731520" y="1371600"/>
+            <a:ext cx="10698480" cy="4754880"/>
+          </a:xfrm>
+          <a:prstGeom prst="rect">
+            <a:avLst/>
+          </a:prstGeom>
+          <a:noFill/>
+        </p:spPr>
+        <p:txBody>
+          <a:bodyPr wrap="square">
+            <a:spAutoFit/>
+          </a:bodyPr>
+          <a:lstStyle/>
+          <a:p>
+            <a:r>
+              <a:rPr sz="1450" b="1">
                 <a:solidFill>
                   <a:srgbClr val="0A3663"/>
                 </a:solidFill>
               </a:rPr>
-              <a:t>Benchmark Scope: </a:t>
-            </a:r>
-            <a:r>
-              <a:rPr>
-                <a:solidFill>
-                  <a:srgbClr val="3C3C3C"/>
+              <a:t>Vargas et al. (2019, 2026) — Petrobras 3W Benchmark: </a:t>
+            </a:r>
+            <a:r>
+              <a:rPr sz="1450" b="0"/>
+              <a:t>Introduced 3W. Evaluates macroscopic fault classification F1-scores, but does not measure advance warning lead times before T_transient or false alarms per operating hour.
+</a:t>
+            </a:r>
+            <a:r>
+              <a:rPr sz="1450" b="1">
+                <a:solidFill>
+                  <a:srgbClr val="0A3663"/>
                 </a:solidFill>
               </a:rPr>
-              <a:t>2,228 files (1.87 GB) across 8 fault classes from offshore Brazilian basins.</a:t>
-            </a:r>
-          </a:p>
-          <a:p>
-            <a:pPr>
-              <a:spcBef>
-                <a:spcPts val="1000"/>
-              </a:spcBef>
-              <a:defRPr sz="1500"/>
-            </a:pPr>
-            <a:r>
-              <a:rPr b="1">
+              <a:t>Fernandes Jr. et al. (2023/2024) — One-Class Classifiers: </a:t>
+            </a:r>
+            <a:r>
+              <a:rPr sz="1450" b="0"/>
+              <a:t>Demonstrated that Local Outlier Factor (LOF) outperforms Isolation Forest and Autoencoders on 3W (F1 ~87%). However, outlier scores lack operational false-alarm constraints.
+</a:t>
+            </a:r>
+            <a:r>
+              <a:rPr sz="1450" b="1">
                 <a:solidFill>
                   <a:srgbClr val="0A3663"/>
                 </a:solidFill>
               </a:rPr>
-              <a:t>Strict Gold Cohort (N=19): </a:t>
-            </a:r>
-            <a:r>
-              <a:rPr>
-                <a:solidFill>
-                  <a:srgbClr val="3C3C3C"/>
+              <a:t>Wang et al. (2024) &amp; Khan et al. (2026): </a:t>
+            </a:r>
+            <a:r>
+              <a:rPr sz="1450" b="0"/>
+              <a:t>Motivated combining prediction residuals with cross-sensor relational shifts and calibrating thresholds under false-alarm budgets.
+</a:t>
+            </a:r>
+            <a:r>
+              <a:rPr sz="1450" b="1">
+                <a:solidFill>
+                  <a:srgbClr val="0A3663"/>
                 </a:solidFill>
               </a:rPr>
-              <a:t>Audited 22 real-well Class 2 candidates; 19 gold events accepted. Excluded 3 files (including 1 constant flatline sensor file).</a:t>
-            </a:r>
-          </a:p>
-          <a:p>
-            <a:pPr>
-              <a:spcBef>
-                <a:spcPts val="1000"/>
-              </a:spcBef>
-              <a:defRPr sz="1500"/>
-            </a:pPr>
-            <a:r>
-              <a:rPr b="1">
-                <a:solidFill>
-                  <a:srgbClr val="0A3663"/>
-                </a:solidFill>
-              </a:rPr>
-              <a:t>Sensor Selection: </a:t>
-            </a:r>
-            <a:r>
-              <a:rPr>
-                <a:solidFill>
-                  <a:srgbClr val="3C3C3C"/>
-                </a:solidFill>
-              </a:rPr>
-              <a:t>Target: P-TPT (downhole pressure, MPa); Exogenous: T-TPT (downhole temperature, degC).</a:t>
-            </a:r>
-          </a:p>
-          <a:p>
-            <a:pPr>
-              <a:spcBef>
-                <a:spcPts val="1000"/>
-              </a:spcBef>
-              <a:defRPr sz="1500"/>
-            </a:pPr>
-            <a:r>
-              <a:rPr b="1">
-                <a:solidFill>
-                  <a:srgbClr val="0A3663"/>
-                </a:solidFill>
-              </a:rPr>
-              <a:t>Resampling &amp; Preprocessing: </a:t>
-            </a:r>
-            <a:r>
-              <a:rPr>
-                <a:solidFill>
-                  <a:srgbClr val="3C3C3C"/>
-                </a:solidFill>
-              </a:rPr>
-              <a:t>Uniform 10s resampling with forward-fill limit of 6 raw samples; audited for flatline and long-gap anomalies.</a:t>
-            </a:r>
-          </a:p>
-          <a:p>
-            <a:pPr>
-              <a:spcBef>
-                <a:spcPts val="1000"/>
-              </a:spcBef>
-              <a:defRPr sz="1500"/>
-            </a:pPr>
-            <a:r>
-              <a:rPr b="1">
-                <a:solidFill>
-                  <a:srgbClr val="0A3663"/>
-                </a:solidFill>
-              </a:rPr>
-              <a:t>Strict Chronological Partitioning: </a:t>
-            </a:r>
-            <a:r>
-              <a:rPr>
-                <a:solidFill>
-                  <a:srgbClr val="3C3C3C"/>
-                </a:solidFill>
-              </a:rPr>
-              <a:t>60% Training (model fitting) | 20% Calibration (threshold calibration) | 20% Holdout + Full Transient (evaluation).</a:t>
+              <a:t>The Research Gap: </a:t>
+            </a:r>
+            <a:r>
+              <a:rPr sz="1450" b="0"/>
+              <a:t>No existing 3W study evaluates early warning lead times strictly prior to transient onset under an explicit false-alarm budget, nor validates multisensor coupling against non-forecasting baselines (LOF) under leak-free cross-validation.</a:t>
             </a:r>
           </a:p>
         </p:txBody>
@@ -3668,59 +3517,14 @@
       <p:grpSpPr/>
       <p:sp>
         <p:nvSpPr>
-          <p:cNvPr id="2" name="Rounded Rectangle 1"/>
-          <p:cNvSpPr/>
+          <p:cNvPr id="2" name="TextBox 1"/>
+          <p:cNvSpPr txBox="1"/>
           <p:nvPr/>
         </p:nvSpPr>
         <p:spPr>
           <a:xfrm>
-            <a:off x="731520" y="548640"/>
-            <a:ext cx="10728655" cy="5760720"/>
-          </a:xfrm>
-          <a:prstGeom prst="roundRect">
-            <a:avLst/>
-          </a:prstGeom>
-          <a:solidFill>
-            <a:srgbClr val="F8FAFC"/>
-          </a:solidFill>
-          <a:ln>
-            <a:solidFill>
-              <a:srgbClr val="F8FAFC"/>
-            </a:solidFill>
-          </a:ln>
-        </p:spPr>
-        <p:style>
-          <a:lnRef idx="1">
-            <a:schemeClr val="accent1"/>
-          </a:lnRef>
-          <a:fillRef idx="3">
-            <a:schemeClr val="accent1"/>
-          </a:fillRef>
-          <a:effectRef idx="2">
-            <a:schemeClr val="accent1"/>
-          </a:effectRef>
-          <a:fontRef idx="minor">
-            <a:schemeClr val="lt1"/>
-          </a:fontRef>
-        </p:style>
-        <p:txBody>
-          <a:bodyPr rtlCol="0" anchor="ctr"/>
-          <a:lstStyle/>
-          <a:p>
-            <a:pPr algn="ctr"/>
-          </a:p>
-        </p:txBody>
-      </p:sp>
-      <p:sp>
-        <p:nvSpPr>
-          <p:cNvPr id="3" name="TextBox 2"/>
-          <p:cNvSpPr txBox="1"/>
-          <p:nvPr/>
-        </p:nvSpPr>
-        <p:spPr>
-          <a:xfrm>
-            <a:off x="1097280" y="822960"/>
-            <a:ext cx="10058400" cy="5120640"/>
+            <a:off x="731520" y="365760"/>
+            <a:ext cx="10698480" cy="914400"/>
           </a:xfrm>
           <a:prstGeom prst="rect">
             <a:avLst/>
@@ -3734,134 +3538,128 @@
           <a:lstStyle/>
           <a:p>
             <a:pPr>
-              <a:defRPr sz="2600" b="1">
-                <a:solidFill>
-                  <a:srgbClr val="0A3663"/>
+              <a:defRPr sz="1000" b="1">
+                <a:solidFill>
+                  <a:srgbClr val="2B5C8F"/>
                 </a:solidFill>
               </a:defRPr>
             </a:pPr>
             <a:r>
-              <a:t>Forecasting Accuracy: ARIMA &amp; SARIMAX vs. Naive Baseline</a:t>
+              <a:t>DATA INTEGRITY</a:t>
             </a:r>
           </a:p>
           <a:p>
             <a:pPr>
-              <a:spcBef>
-                <a:spcPts val="1000"/>
-              </a:spcBef>
-              <a:defRPr sz="1500"/>
+              <a:defRPr sz="2200" b="1">
+                <a:solidFill>
+                  <a:srgbClr val="0A3663"/>
+                </a:solidFill>
+              </a:defRPr>
             </a:pPr>
             <a:r>
-              <a:rPr b="1">
+              <a:t>Petrobras 3W Cohort Resolution: Exactly 19 Gold-Standard Events</a:t>
+            </a:r>
+          </a:p>
+        </p:txBody>
+      </p:sp>
+      <p:sp>
+        <p:nvSpPr>
+          <p:cNvPr id="3" name="TextBox 2"/>
+          <p:cNvSpPr txBox="1"/>
+          <p:nvPr/>
+        </p:nvSpPr>
+        <p:spPr>
+          <a:xfrm>
+            <a:off x="731520" y="1371600"/>
+            <a:ext cx="10698480" cy="4754880"/>
+          </a:xfrm>
+          <a:prstGeom prst="rect">
+            <a:avLst/>
+          </a:prstGeom>
+          <a:noFill/>
+        </p:spPr>
+        <p:txBody>
+          <a:bodyPr wrap="square">
+            <a:spAutoFit/>
+          </a:bodyPr>
+          <a:lstStyle/>
+          <a:p>
+            <a:r>
+              <a:rPr sz="1450" b="1">
                 <a:solidFill>
                   <a:srgbClr val="0A3663"/>
                 </a:solidFill>
               </a:rPr>
-              <a:t>ARIMA Test MAE: </a:t>
-            </a:r>
-            <a:r>
-              <a:rPr>
-                <a:solidFill>
-                  <a:srgbClr val="3C3C3C"/>
+              <a:t>Candidate Filtering: </a:t>
+            </a:r>
+            <a:r>
+              <a:rPr sz="1450" b="0"/>
+              <a:t>2,228 instances in 3W v2.0.0. Exclusively authentic production well instances (WELL-*) experiencing Class 2 were extracted (22 candidate events).
+</a:t>
+            </a:r>
+            <a:r>
+              <a:rPr sz="1450" b="1">
+                <a:solidFill>
+                  <a:srgbClr val="0A3663"/>
                 </a:solidFill>
               </a:rPr>
-              <a:t>0.0163 MPa (vs. Naive 0.0307 MPa) -&gt; 47.1% Lower Forecasting Error!</a:t>
-            </a:r>
-          </a:p>
-          <a:p>
-            <a:pPr>
-              <a:spcBef>
-                <a:spcPts val="1000"/>
-              </a:spcBef>
-              <a:defRPr sz="1500"/>
-            </a:pPr>
-            <a:r>
-              <a:rPr b="1">
+              <a:t>Quality Audit Exclusions: </a:t>
+            </a:r>
+            <a:r>
+              <a:rPr sz="1450" b="0"/>
+              <a:t>Three corrupt instances were rigorously removed:
+</a:t>
+            </a:r>
+            <a:r>
+              <a:rPr sz="1450" b="1">
                 <a:solidFill>
                   <a:srgbClr val="0A3663"/>
                 </a:solidFill>
               </a:rPr>
-              <a:t>ARIMA Test RMSE: </a:t>
-            </a:r>
-            <a:r>
-              <a:rPr>
-                <a:solidFill>
-                  <a:srgbClr val="3C3C3C"/>
+              <a:t>  • WELL-00010_20171218180131: </a:t>
+            </a:r>
+            <a:r>
+              <a:rPr sz="1450" b="0"/>
+              <a:t>Load failure; pressure sensor stream absent.
+</a:t>
+            </a:r>
+            <a:r>
+              <a:rPr sz="1450" b="1">
+                <a:solidFill>
+                  <a:srgbClr val="0A3663"/>
                 </a:solidFill>
               </a:rPr>
-              <a:t>0.0524 MPa (vs. Naive 0.0781 MPa) -&gt; 32.9% Lower Root Mean Squared Error!</a:t>
-            </a:r>
-          </a:p>
-          <a:p>
-            <a:pPr>
-              <a:spcBef>
-                <a:spcPts val="1000"/>
-              </a:spcBef>
-              <a:defRPr sz="1500"/>
-            </a:pPr>
-            <a:r>
-              <a:rPr b="1">
+              <a:t>  • WELL-00011_20140515083000: </a:t>
+            </a:r>
+            <a:r>
+              <a:rPr sz="1450" b="0"/>
+              <a:t>Sensor telemetry gap of 1,608 seconds (&gt;10 minutes).
+</a:t>
+            </a:r>
+            <a:r>
+              <a:rPr sz="1450" b="1">
                 <a:solidFill>
                   <a:srgbClr val="0A3663"/>
                 </a:solidFill>
               </a:rPr>
-              <a:t>ARIMA Test MAPE: </a:t>
-            </a:r>
-            <a:r>
-              <a:rPr>
-                <a:solidFill>
-                  <a:srgbClr val="3C3C3C"/>
+              <a:t>  • WELL-00002_20131104004101: </a:t>
+            </a:r>
+            <a:r>
+              <a:rPr sz="1450" b="0"/>
+              <a:t>Zero variance in normal training target (flatline, std = 0.0).
+</a:t>
+            </a:r>
+            <a:r>
+              <a:rPr sz="1450" b="1">
+                <a:solidFill>
+                  <a:srgbClr val="0A3663"/>
                 </a:solidFill>
               </a:rPr>
-              <a:t>8.69% (vs. Naive 18.22%) -&gt; Over 52% reduction in relative percentage error!</a:t>
-            </a:r>
-          </a:p>
-          <a:p>
-            <a:pPr>
-              <a:spcBef>
-                <a:spcPts val="1000"/>
-              </a:spcBef>
-              <a:defRPr sz="1500"/>
-            </a:pPr>
-            <a:r>
-              <a:rPr b="1">
-                <a:solidFill>
-                  <a:srgbClr val="0A3663"/>
-                </a:solidFill>
-              </a:rPr>
-              <a:t>Validation R2 Score: </a:t>
-            </a:r>
-            <a:r>
-              <a:rPr>
-                <a:solidFill>
-                  <a:srgbClr val="3C3C3C"/>
-                </a:solidFill>
-              </a:rPr>
-              <a:t>ARIMA: 0.9107 | SARIMAX: 0.9025 | Naive Baseline: 0.7887</a:t>
-            </a:r>
-          </a:p>
-          <a:p>
-            <a:pPr>
-              <a:spcBef>
-                <a:spcPts val="1000"/>
-              </a:spcBef>
-              <a:defRPr sz="1500"/>
-            </a:pPr>
-            <a:r>
-              <a:rPr b="1">
-                <a:solidFill>
-                  <a:srgbClr val="0A3663"/>
-                </a:solidFill>
-              </a:rPr>
-              <a:t>Key Finding: </a:t>
-            </a:r>
-            <a:r>
-              <a:rPr>
-                <a:solidFill>
-                  <a:srgbClr val="3C3C3C"/>
-                </a:solidFill>
-              </a:rPr>
-              <a:t>Statistical TSA models capture autocorrelation and exogenous thermal dynamics, drastically outperforming naive extrapolation.</a:t>
+              <a:t>Denominator Resolution: </a:t>
+            </a:r>
+            <a:r>
+              <a:rPr sz="1450" b="0"/>
+              <a:t>Immutable gold cohort of exactly 19 events. The earlier 20-event discrepancy was resolved by removing a stale uncleaned parquet artifact from a preliminary scan.</a:t>
             </a:r>
           </a:p>
         </p:txBody>
@@ -3886,59 +3684,14 @@
       <p:grpSpPr/>
       <p:sp>
         <p:nvSpPr>
-          <p:cNvPr id="2" name="Rounded Rectangle 1"/>
-          <p:cNvSpPr/>
+          <p:cNvPr id="2" name="TextBox 1"/>
+          <p:cNvSpPr txBox="1"/>
           <p:nvPr/>
         </p:nvSpPr>
         <p:spPr>
           <a:xfrm>
-            <a:off x="731520" y="548640"/>
-            <a:ext cx="10728655" cy="5760720"/>
-          </a:xfrm>
-          <a:prstGeom prst="roundRect">
-            <a:avLst/>
-          </a:prstGeom>
-          <a:solidFill>
-            <a:srgbClr val="F8FAFC"/>
-          </a:solidFill>
-          <a:ln>
-            <a:solidFill>
-              <a:srgbClr val="F8FAFC"/>
-            </a:solidFill>
-          </a:ln>
-        </p:spPr>
-        <p:style>
-          <a:lnRef idx="1">
-            <a:schemeClr val="accent1"/>
-          </a:lnRef>
-          <a:fillRef idx="3">
-            <a:schemeClr val="accent1"/>
-          </a:fillRef>
-          <a:effectRef idx="2">
-            <a:schemeClr val="accent1"/>
-          </a:effectRef>
-          <a:fontRef idx="minor">
-            <a:schemeClr val="lt1"/>
-          </a:fontRef>
-        </p:style>
-        <p:txBody>
-          <a:bodyPr rtlCol="0" anchor="ctr"/>
-          <a:lstStyle/>
-          <a:p>
-            <a:pPr algn="ctr"/>
-          </a:p>
-        </p:txBody>
-      </p:sp>
-      <p:sp>
-        <p:nvSpPr>
-          <p:cNvPr id="3" name="TextBox 2"/>
-          <p:cNvSpPr txBox="1"/>
-          <p:nvPr/>
-        </p:nvSpPr>
-        <p:spPr>
-          <a:xfrm>
-            <a:off x="1097280" y="822960"/>
-            <a:ext cx="10058400" cy="5120640"/>
+            <a:off x="731520" y="365760"/>
+            <a:ext cx="10698480" cy="914400"/>
           </a:xfrm>
           <a:prstGeom prst="rect">
             <a:avLst/>
@@ -3952,138 +3705,143 @@
           <a:lstStyle/>
           <a:p>
             <a:pPr>
-              <a:defRPr sz="2600" b="1">
-                <a:solidFill>
-                  <a:srgbClr val="0A3663"/>
+              <a:defRPr sz="1000" b="1">
+                <a:solidFill>
+                  <a:srgbClr val="2B5C8F"/>
                 </a:solidFill>
               </a:defRPr>
             </a:pPr>
             <a:r>
-              <a:t>Audit of Early-Warning Evaluation Rules</a:t>
+              <a:t>STATISTICAL RIGOR</a:t>
             </a:r>
           </a:p>
           <a:p>
             <a:pPr>
-              <a:spcBef>
-                <a:spcPts val="1000"/>
-              </a:spcBef>
-              <a:defRPr sz="1500"/>
+              <a:defRPr sz="2200" b="1">
+                <a:solidFill>
+                  <a:srgbClr val="0A3663"/>
+                </a:solidFill>
+              </a:defRPr>
             </a:pPr>
             <a:r>
-              <a:rPr b="1">
+              <a:t>Forecasting Superiority: ARIMA &amp; SARIMAX Cut Error by 47%</a:t>
+            </a:r>
+          </a:p>
+        </p:txBody>
+      </p:sp>
+      <p:sp>
+        <p:nvSpPr>
+          <p:cNvPr id="3" name="TextBox 2"/>
+          <p:cNvSpPr txBox="1"/>
+          <p:nvPr/>
+        </p:nvSpPr>
+        <p:spPr>
+          <a:xfrm>
+            <a:off x="731520" y="1371600"/>
+            <a:ext cx="5486400" cy="4754880"/>
+          </a:xfrm>
+          <a:prstGeom prst="rect">
+            <a:avLst/>
+          </a:prstGeom>
+          <a:noFill/>
+        </p:spPr>
+        <p:txBody>
+          <a:bodyPr wrap="square">
+            <a:spAutoFit/>
+          </a:bodyPr>
+          <a:lstStyle/>
+          <a:p>
+            <a:r>
+              <a:rPr sz="1400" b="1">
                 <a:solidFill>
                   <a:srgbClr val="0A3663"/>
                 </a:solidFill>
               </a:rPr>
-              <a:t>The Anomaly in Default Rules: </a:t>
-            </a:r>
-            <a:r>
-              <a:rPr>
-                <a:solidFill>
-                  <a:srgbClr val="3C3C3C"/>
+              <a:t>Rolling 1-Step Forecasts: </a:t>
+            </a:r>
+            <a:r>
+              <a:rPr sz="1400" b="0"/>
+              <a:t>Evaluated on untouched test split across all 19 gold events.
+</a:t>
+            </a:r>
+            <a:r>
+              <a:rPr sz="1400" b="1">
+                <a:solidFill>
+                  <a:srgbClr val="0A3663"/>
                 </a:solidFill>
               </a:rPr>
-              <a:t>Under unoptimized static settings (q=0.99, p=3), Naive reported 7/19 early detections vs. 5/19 for ARIMA.</a:t>
-            </a:r>
-          </a:p>
-          <a:p>
-            <a:pPr>
-              <a:spcBef>
-                <a:spcPts val="1000"/>
-              </a:spcBef>
-              <a:defRPr sz="1500"/>
-            </a:pPr>
-            <a:r>
-              <a:rPr b="1">
+              <a:t>ARIMA(p, d, q): </a:t>
+            </a:r>
+            <a:r>
+              <a:rPr sz="1400" b="0"/>
+              <a:t>MAE = 0.0163 MPa | RMSE = 0.0524 MPa | MAPE = 8.69% | R² = 0.9994.
+</a:t>
+            </a:r>
+            <a:r>
+              <a:rPr sz="1400" b="1">
                 <a:solidFill>
                   <a:srgbClr val="0A3663"/>
                 </a:solidFill>
               </a:rPr>
-              <a:t>Audited Window Policy: </a:t>
-            </a:r>
-            <a:r>
-              <a:rPr>
-                <a:solidFill>
-                  <a:srgbClr val="3C3C3C"/>
+              <a:t>SARIMAX (+T-TPT): </a:t>
+            </a:r>
+            <a:r>
+              <a:rPr sz="1400" b="0"/>
+              <a:t>MAE = 0.0162 MPa | RMSE = 0.0523 MPa | MAPE = 8.63% | R² = 0.9994.
+</a:t>
+            </a:r>
+            <a:r>
+              <a:rPr sz="1400" b="1">
+                <a:solidFill>
+                  <a:srgbClr val="0A3663"/>
                 </a:solidFill>
               </a:rPr>
-              <a:t>Early warnings must strictly occur inside the 10-minute pre-event window [t_transient - 10m, t_transient).</a:t>
-            </a:r>
-          </a:p>
-          <a:p>
-            <a:pPr>
-              <a:spcBef>
-                <a:spcPts val="1000"/>
-              </a:spcBef>
-              <a:defRPr sz="1500"/>
-            </a:pPr>
-            <a:r>
-              <a:rPr b="1">
+              <a:t>Naive Persistence Baseline: </a:t>
+            </a:r>
+            <a:r>
+              <a:rPr sz="1400" b="0"/>
+              <a:t>MAE = 0.0307 MPa | RMSE = 0.0781 MPa | MAPE = 18.22% | R² = 0.9988.
+</a:t>
+            </a:r>
+            <a:r>
+              <a:rPr sz="1400" b="1">
                 <a:solidFill>
                   <a:srgbClr val="0A3663"/>
                 </a:solidFill>
               </a:rPr>
-              <a:t>False Alarm Separation: </a:t>
-            </a:r>
-            <a:r>
-              <a:rPr>
-                <a:solidFill>
-                  <a:srgbClr val="3C3C3C"/>
-                </a:solidFill>
-              </a:rPr>
-              <a:t>Alarms occurring during ordinary normal operation (before the pre-event window) are counted strictly as false alarms.</a:t>
-            </a:r>
-          </a:p>
-          <a:p>
-            <a:pPr>
-              <a:spcBef>
-                <a:spcPts val="1000"/>
-              </a:spcBef>
-              <a:defRPr sz="1500"/>
-            </a:pPr>
-            <a:r>
-              <a:rPr b="1">
-                <a:solidFill>
-                  <a:srgbClr val="0A3663"/>
-                </a:solidFill>
-              </a:rPr>
-              <a:t>Lead Time Integrity: </a:t>
-            </a:r>
-            <a:r>
-              <a:rPr>
-                <a:solidFill>
-                  <a:srgbClr val="3C3C3C"/>
-                </a:solidFill>
-              </a:rPr>
-              <a:t>Lead times are calculated strictly from the pre-event alarm, guaranteeing bounded lead times (0 &lt;= lead &lt;= 10 min).</a:t>
-            </a:r>
-          </a:p>
-          <a:p>
-            <a:pPr>
-              <a:spcBef>
-                <a:spcPts val="1000"/>
-              </a:spcBef>
-              <a:defRPr sz="1500"/>
-            </a:pPr>
-            <a:r>
-              <a:rPr b="1">
-                <a:solidFill>
-                  <a:srgbClr val="0A3663"/>
-                </a:solidFill>
-              </a:rPr>
-              <a:t>Denominator Integrity: </a:t>
-            </a:r>
-            <a:r>
-              <a:rPr>
-                <a:solidFill>
-                  <a:srgbClr val="3C3C3C"/>
-                </a:solidFill>
-              </a:rPr>
-              <a:t>All metrics use exactly the 19 evaluated gold events as the denominator.</a:t>
-            </a:r>
-          </a:p>
-        </p:txBody>
-      </p:sp>
+              <a:t>Takeaway: </a:t>
+            </a:r>
+            <a:r>
+              <a:rPr sz="1400" b="0"/>
+              <a:t>Statistical TSA models capture authentic downhole physical dynamics with nearly half the error of persistence baselines.</a:t>
+            </a:r>
+          </a:p>
+        </p:txBody>
+      </p:sp>
+      <p:pic>
+        <p:nvPicPr>
+          <p:cNvPr id="4" name="Picture 3" descr="forecast_accuracy.png"/>
+          <p:cNvPicPr>
+            <a:picLocks noChangeAspect="1"/>
+          </p:cNvPicPr>
+          <p:nvPr/>
+        </p:nvPicPr>
+        <p:blipFill>
+          <a:blip r:embed="rId2"/>
+          <a:stretch>
+            <a:fillRect/>
+          </a:stretch>
+        </p:blipFill>
+        <p:spPr>
+          <a:xfrm>
+            <a:off x="6583680" y="1463040"/>
+            <a:ext cx="5029200" cy="4389120"/>
+          </a:xfrm>
+          <a:prstGeom prst="rect">
+            <a:avLst/>
+          </a:prstGeom>
+        </p:spPr>
+      </p:pic>
     </p:spTree>
   </p:cSld>
   <p:clrMapOvr>
@@ -4104,59 +3862,14 @@
       <p:grpSpPr/>
       <p:sp>
         <p:nvSpPr>
-          <p:cNvPr id="2" name="Rounded Rectangle 1"/>
-          <p:cNvSpPr/>
+          <p:cNvPr id="2" name="TextBox 1"/>
+          <p:cNvSpPr txBox="1"/>
           <p:nvPr/>
         </p:nvSpPr>
         <p:spPr>
           <a:xfrm>
-            <a:off x="731520" y="548640"/>
-            <a:ext cx="10728655" cy="5760720"/>
-          </a:xfrm>
-          <a:prstGeom prst="roundRect">
-            <a:avLst/>
-          </a:prstGeom>
-          <a:solidFill>
-            <a:srgbClr val="F8FAFC"/>
-          </a:solidFill>
-          <a:ln>
-            <a:solidFill>
-              <a:srgbClr val="F8FAFC"/>
-            </a:solidFill>
-          </a:ln>
-        </p:spPr>
-        <p:style>
-          <a:lnRef idx="1">
-            <a:schemeClr val="accent1"/>
-          </a:lnRef>
-          <a:fillRef idx="3">
-            <a:schemeClr val="accent1"/>
-          </a:fillRef>
-          <a:effectRef idx="2">
-            <a:schemeClr val="accent1"/>
-          </a:effectRef>
-          <a:fontRef idx="minor">
-            <a:schemeClr val="lt1"/>
-          </a:fontRef>
-        </p:style>
-        <p:txBody>
-          <a:bodyPr rtlCol="0" anchor="ctr"/>
-          <a:lstStyle/>
-          <a:p>
-            <a:pPr algn="ctr"/>
-          </a:p>
-        </p:txBody>
-      </p:sp>
-      <p:sp>
-        <p:nvSpPr>
-          <p:cNvPr id="3" name="TextBox 2"/>
-          <p:cNvSpPr txBox="1"/>
-          <p:nvPr/>
-        </p:nvSpPr>
-        <p:spPr>
-          <a:xfrm>
-            <a:off x="1097280" y="822960"/>
-            <a:ext cx="10058400" cy="5120640"/>
+            <a:off x="731520" y="365760"/>
+            <a:ext cx="10698480" cy="914400"/>
           </a:xfrm>
           <a:prstGeom prst="rect">
             <a:avLst/>
@@ -4170,134 +3883,102 @@
           <a:lstStyle/>
           <a:p>
             <a:pPr>
-              <a:defRPr sz="2600" b="1">
-                <a:solidFill>
-                  <a:srgbClr val="0A3663"/>
+              <a:defRPr sz="1000" b="1">
+                <a:solidFill>
+                  <a:srgbClr val="2B5C8F"/>
                 </a:solidFill>
               </a:defRPr>
             </a:pPr>
             <a:r>
-              <a:t>Unbiased Generalization: Leave-One-Event-Out Cross-Validation</a:t>
+              <a:t>NOVEL EXTENSION</a:t>
             </a:r>
           </a:p>
           <a:p>
             <a:pPr>
-              <a:spcBef>
-                <a:spcPts val="1000"/>
-              </a:spcBef>
-              <a:defRPr sz="1500"/>
+              <a:defRPr sz="2200" b="1">
+                <a:solidFill>
+                  <a:srgbClr val="0A3663"/>
+                </a:solidFill>
+              </a:defRPr>
             </a:pPr>
             <a:r>
-              <a:rPr b="1">
+              <a:t>OILGUARD-AC: Alarm-Constrained Multisensor Early Warning</a:t>
+            </a:r>
+          </a:p>
+        </p:txBody>
+      </p:sp>
+      <p:sp>
+        <p:nvSpPr>
+          <p:cNvPr id="3" name="TextBox 2"/>
+          <p:cNvSpPr txBox="1"/>
+          <p:nvPr/>
+        </p:nvSpPr>
+        <p:spPr>
+          <a:xfrm>
+            <a:off x="731520" y="1371600"/>
+            <a:ext cx="10698480" cy="4754880"/>
+          </a:xfrm>
+          <a:prstGeom prst="rect">
+            <a:avLst/>
+          </a:prstGeom>
+          <a:noFill/>
+        </p:spPr>
+        <p:txBody>
+          <a:bodyPr wrap="square">
+            <a:spAutoFit/>
+          </a:bodyPr>
+          <a:lstStyle/>
+          <a:p>
+            <a:r>
+              <a:rPr sz="1450" b="1">
                 <a:solidFill>
                   <a:srgbClr val="0A3663"/>
                 </a:solidFill>
               </a:rPr>
-              <a:t>Preventing Data Leakage: </a:t>
-            </a:r>
-            <a:r>
-              <a:rPr>
-                <a:solidFill>
-                  <a:srgbClr val="3C3C3C"/>
+              <a:t>1. Bivariate Thermodynamic Residual Score: </a:t>
+            </a:r>
+            <a:r>
+              <a:rPr sz="1450" b="0"/>
+              <a:t>Combines standardized pressure forecast residual z_P with standardized temperature deviation z_T: S_t = sqrt(w_P * z_P^2 + (1 - w_P) * z_T^2).
+</a:t>
+            </a:r>
+            <a:r>
+              <a:rPr sz="1450" b="1">
+                <a:solidFill>
+                  <a:srgbClr val="0A3663"/>
                 </a:solidFill>
               </a:rPr>
-              <a:t>Retrospective grid search on holdout sets causes leakage. To guarantee unbiased evaluation, LOEO-CV was executed.</a:t>
-            </a:r>
-          </a:p>
-          <a:p>
-            <a:pPr>
-              <a:spcBef>
-                <a:spcPts val="1000"/>
-              </a:spcBef>
-              <a:defRPr sz="1500"/>
-            </a:pPr>
-            <a:r>
-              <a:rPr b="1">
+              <a:t>2. False-Alarm-Budgeted Threshold Calibration: </a:t>
+            </a:r>
+            <a:r>
+              <a:rPr sz="1450" b="0"/>
+              <a:t>Replaces unconstrained quantile searches. Threshold tau is calibrated on normal calibration data so that calibration false alarm rate does not exceed an operational budget (e.g., B_FAR &lt;= 1.0 FA/hr).
+</a:t>
+            </a:r>
+            <a:r>
+              <a:rPr sz="1450" b="1">
                 <a:solidFill>
                   <a:srgbClr val="0A3663"/>
                 </a:solidFill>
               </a:rPr>
-              <a:t>ARIMA LOEO-CV Detection: </a:t>
-            </a:r>
-            <a:r>
-              <a:rPr>
-                <a:solidFill>
-                  <a:srgbClr val="3C3C3C"/>
+              <a:t>3. Strict Pre-Event Warning Policy: </a:t>
+            </a:r>
+            <a:r>
+              <a:rPr sz="1450" b="0"/>
+              <a:t>Valid early warning window is strictly [T_transient - 10 min, T_transient). Alarms prior to this window count as ordinary false alarms, preventing misclassification.
+</a:t>
+            </a:r>
+            <a:r>
+              <a:rPr sz="1450" b="1">
+                <a:solidFill>
+                  <a:srgbClr val="0A3663"/>
                 </a:solidFill>
               </a:rPr>
-              <a:t>ARIMA achieves 42.1% early detection (8/19 events) with 5.10 minutes advance lead time.</a:t>
-            </a:r>
-          </a:p>
-          <a:p>
-            <a:pPr>
-              <a:spcBef>
-                <a:spcPts val="1000"/>
-              </a:spcBef>
-              <a:defRPr sz="1500"/>
-            </a:pPr>
-            <a:r>
-              <a:rPr b="1">
-                <a:solidFill>
-                  <a:srgbClr val="0A3663"/>
-                </a:solidFill>
-              </a:rPr>
-              <a:t>Naive Baseline LOEO-CV: </a:t>
-            </a:r>
-            <a:r>
-              <a:rPr>
-                <a:solidFill>
-                  <a:srgbClr val="3C3C3C"/>
-                </a:solidFill>
-              </a:rPr>
-              <a:t>Naive baseline achieves 36.8% early detection (7/19 events) with 1.69 minutes lead time.</a:t>
-            </a:r>
-          </a:p>
-          <a:p>
-            <a:pPr>
-              <a:spcBef>
-                <a:spcPts val="1000"/>
-              </a:spcBef>
-              <a:defRPr sz="1500"/>
-            </a:pPr>
-            <a:r>
-              <a:rPr b="1">
-                <a:solidFill>
-                  <a:srgbClr val="0A3663"/>
-                </a:solidFill>
-              </a:rPr>
-              <a:t>The Lead Time Advantage: </a:t>
-            </a:r>
-            <a:r>
-              <a:rPr>
-                <a:solidFill>
-                  <a:srgbClr val="3C3C3C"/>
-                </a:solidFill>
-              </a:rPr>
-              <a:t>ARIMA delivers over 3x the advance warning lead time of the baseline (5.10 min vs. 1.69 min)!</a:t>
-            </a:r>
-          </a:p>
-          <a:p>
-            <a:pPr>
-              <a:spcBef>
-                <a:spcPts val="1000"/>
-              </a:spcBef>
-              <a:defRPr sz="1500"/>
-            </a:pPr>
-            <a:r>
-              <a:rPr b="1">
-                <a:solidFill>
-                  <a:srgbClr val="0A3663"/>
-                </a:solidFill>
-              </a:rPr>
-              <a:t>Conclusion: </a:t>
-            </a:r>
-            <a:r>
-              <a:rPr>
-                <a:solidFill>
-                  <a:srgbClr val="3C3C3C"/>
-                </a:solidFill>
-              </a:rPr>
-              <a:t>In honest cross-validation, statistical TSA models outperform the baseline in both detection rate and reaction window.</a:t>
+              <a:t>4. Leak-Free Leave-One-Event-Out Validation: </a:t>
+            </a:r>
+            <a:r>
+              <a:rPr sz="1450" b="0"/>
+              <a:t>Parameters selected strictly on training folds and tested on unseen holdouts, benchmarked against Local Outlier Factor (LOF).</a:t>
             </a:r>
           </a:p>
         </p:txBody>
@@ -4322,59 +4003,14 @@
       <p:grpSpPr/>
       <p:sp>
         <p:nvSpPr>
-          <p:cNvPr id="2" name="Rounded Rectangle 1"/>
-          <p:cNvSpPr/>
+          <p:cNvPr id="2" name="TextBox 1"/>
+          <p:cNvSpPr txBox="1"/>
           <p:nvPr/>
         </p:nvSpPr>
         <p:spPr>
           <a:xfrm>
-            <a:off x="731520" y="548640"/>
-            <a:ext cx="10728655" cy="5760720"/>
-          </a:xfrm>
-          <a:prstGeom prst="roundRect">
-            <a:avLst/>
-          </a:prstGeom>
-          <a:solidFill>
-            <a:srgbClr val="F8FAFC"/>
-          </a:solidFill>
-          <a:ln>
-            <a:solidFill>
-              <a:srgbClr val="F8FAFC"/>
-            </a:solidFill>
-          </a:ln>
-        </p:spPr>
-        <p:style>
-          <a:lnRef idx="1">
-            <a:schemeClr val="accent1"/>
-          </a:lnRef>
-          <a:fillRef idx="3">
-            <a:schemeClr val="accent1"/>
-          </a:fillRef>
-          <a:effectRef idx="2">
-            <a:schemeClr val="accent1"/>
-          </a:effectRef>
-          <a:fontRef idx="minor">
-            <a:schemeClr val="lt1"/>
-          </a:fontRef>
-        </p:style>
-        <p:txBody>
-          <a:bodyPr rtlCol="0" anchor="ctr"/>
-          <a:lstStyle/>
-          <a:p>
-            <a:pPr algn="ctr"/>
-          </a:p>
-        </p:txBody>
-      </p:sp>
-      <p:sp>
-        <p:nvSpPr>
-          <p:cNvPr id="3" name="TextBox 2"/>
-          <p:cNvSpPr txBox="1"/>
-          <p:nvPr/>
-        </p:nvSpPr>
-        <p:spPr>
-          <a:xfrm>
-            <a:off x="1097280" y="822960"/>
-            <a:ext cx="10058400" cy="5120640"/>
+            <a:off x="731520" y="365760"/>
+            <a:ext cx="10698480" cy="914400"/>
           </a:xfrm>
           <a:prstGeom prst="rect">
             <a:avLst/>
@@ -4388,134 +4024,161 @@
           <a:lstStyle/>
           <a:p>
             <a:pPr>
-              <a:defRPr sz="2600" b="1">
-                <a:solidFill>
-                  <a:srgbClr val="0A3663"/>
+              <a:defRPr sz="1000" b="1">
+                <a:solidFill>
+                  <a:srgbClr val="2B5C8F"/>
                 </a:solidFill>
               </a:defRPr>
             </a:pPr>
             <a:r>
-              <a:t>Sensitivity Analysis &amp; EWMA Residual Filtering</a:t>
+              <a:t>EXPERIMENTAL RESULTS</a:t>
             </a:r>
           </a:p>
           <a:p>
             <a:pPr>
-              <a:spcBef>
-                <a:spcPts val="1000"/>
-              </a:spcBef>
-              <a:defRPr sz="1500"/>
+              <a:defRPr sz="2200" b="1">
+                <a:solidFill>
+                  <a:srgbClr val="0A3663"/>
+                </a:solidFill>
+              </a:defRPr>
             </a:pPr>
             <a:r>
-              <a:rPr b="1">
+              <a:t>Benchmark Comparison: Unbiased LOEO-CV &amp; Bootstrap CIs</a:t>
+            </a:r>
+          </a:p>
+        </p:txBody>
+      </p:sp>
+      <p:pic>
+        <p:nvPicPr>
+          <p:cNvPr id="3" name="Picture 2" descr="oilguard_ac_benchmarks.png"/>
+          <p:cNvPicPr>
+            <a:picLocks noChangeAspect="1"/>
+          </p:cNvPicPr>
+          <p:nvPr/>
+        </p:nvPicPr>
+        <p:blipFill>
+          <a:blip r:embed="rId2"/>
+          <a:stretch>
+            <a:fillRect/>
+          </a:stretch>
+        </p:blipFill>
+        <p:spPr>
+          <a:xfrm>
+            <a:off x="731520" y="1371600"/>
+            <a:ext cx="5669280" cy="4389120"/>
+          </a:xfrm>
+          <a:prstGeom prst="rect">
+            <a:avLst/>
+          </a:prstGeom>
+        </p:spPr>
+      </p:pic>
+      <p:sp>
+        <p:nvSpPr>
+          <p:cNvPr id="4" name="TextBox 3"/>
+          <p:cNvSpPr txBox="1"/>
+          <p:nvPr/>
+        </p:nvSpPr>
+        <p:spPr>
+          <a:xfrm>
+            <a:off x="6583680" y="1371600"/>
+            <a:ext cx="5029200" cy="4572000"/>
+          </a:xfrm>
+          <a:prstGeom prst="rect">
+            <a:avLst/>
+          </a:prstGeom>
+          <a:noFill/>
+        </p:spPr>
+        <p:txBody>
+          <a:bodyPr wrap="square">
+            <a:spAutoFit/>
+          </a:bodyPr>
+          <a:lstStyle/>
+          <a:p>
+            <a:r>
+              <a:rPr sz="1250" b="1">
                 <a:solidFill>
                   <a:srgbClr val="0A3663"/>
                 </a:solidFill>
               </a:rPr>
-              <a:t>Grid Sensitivity Ceiling (p=1, q=0.95): </a:t>
-            </a:r>
-            <a:r>
-              <a:rPr>
-                <a:solidFill>
-                  <a:srgbClr val="3C3C3C"/>
+              <a:t>Budget Robustness (B &lt;= 1.0 FA/hr):
+</a:t>
+            </a:r>
+            <a:r>
+              <a:rPr sz="1250" b="1">
+                <a:solidFill>
+                  <a:srgbClr val="0A3663"/>
                 </a:solidFill>
               </a:rPr>
-              <a:t>ARIMA achieves 63.2% early detection (12/19) with 5.35 min lead time (empirical upper bound under post-hoc selection).</a:t>
-            </a:r>
-          </a:p>
-          <a:p>
-            <a:pPr>
-              <a:spcBef>
-                <a:spcPts val="1000"/>
-              </a:spcBef>
-              <a:defRPr sz="1500"/>
-            </a:pPr>
-            <a:r>
-              <a:rPr b="1">
+              <a:t>• SARIMAX: </a:t>
+            </a:r>
+            <a:r>
+              <a:rPr sz="1250" b="0"/>
+              <a:t>68.4% Detection (13/19) | 5.40m Lead | Realized FAR: 0.75 / hr (Budget Met!)
+</a:t>
+            </a:r>
+            <a:r>
+              <a:rPr sz="1250" b="1">
                 <a:solidFill>
                   <a:srgbClr val="0A3663"/>
                 </a:solidFill>
               </a:rPr>
-              <a:t>EWMA Filtered Residuals (lambda=0.3, q=0.975): </a:t>
-            </a:r>
-            <a:r>
-              <a:rPr>
-                <a:solidFill>
-                  <a:srgbClr val="3C3C3C"/>
+              <a:t>• OILGUARD-AC (w=0.7): </a:t>
+            </a:r>
+            <a:r>
+              <a:rPr sz="1250" b="0"/>
+              <a:t>47.4% Detection (9/19) | 3.78m Lead | Realized FAR: 0.75 / hr (Budget Met!)
+</a:t>
+            </a:r>
+            <a:r>
+              <a:rPr sz="1250" b="1">
+                <a:solidFill>
+                  <a:srgbClr val="0A3663"/>
                 </a:solidFill>
               </a:rPr>
-              <a:t>ARIMA achieves 57.9% early warning (11/19) with 3.53 min lead time at 1.72 FA/hr.</a:t>
-            </a:r>
-          </a:p>
-          <a:p>
-            <a:pPr>
-              <a:spcBef>
-                <a:spcPts val="1000"/>
-              </a:spcBef>
-              <a:defRPr sz="1500"/>
-            </a:pPr>
-            <a:r>
-              <a:rPr b="1">
+              <a:t>• Univariate ARIMA: </a:t>
+            </a:r>
+            <a:r>
+              <a:rPr sz="1250" b="0"/>
+              <a:t>42.1% Detection (8/19) | 4.31m Lead | Realized FAR: 0.50 / hr (Budget Met!)
+</a:t>
+            </a:r>
+            <a:r>
+              <a:rPr sz="1250" b="1">
                 <a:solidFill>
                   <a:srgbClr val="0A3663"/>
                 </a:solidFill>
               </a:rPr>
-              <a:t>Naive Comparison under EWMA: </a:t>
-            </a:r>
-            <a:r>
-              <a:rPr>
-                <a:solidFill>
-                  <a:srgbClr val="3C3C3C"/>
+              <a:t>• Naive Baseline: </a:t>
+            </a:r>
+            <a:r>
+              <a:rPr sz="1250" b="0"/>
+              <a:t>47.4% Detection (9/19) | 4.48m Lead | Realized FAR: 0.50 / hr (Budget Met!)
+</a:t>
+            </a:r>
+            <a:r>
+              <a:rPr sz="1250" b="1">
+                <a:solidFill>
+                  <a:srgbClr val="0A3663"/>
                 </a:solidFill>
               </a:rPr>
-              <a:t>Naive achieves 42.1% (8/19) -&gt; ARIMA provides a +15.8% advantage at identical false alarm rate.</a:t>
-            </a:r>
-          </a:p>
-          <a:p>
-            <a:pPr>
-              <a:spcBef>
-                <a:spcPts val="1000"/>
-              </a:spcBef>
-              <a:defRPr sz="1500"/>
-            </a:pPr>
-            <a:r>
-              <a:rPr b="1">
+              <a:t>• Local Outlier Factor (LOF): </a:t>
+            </a:r>
+            <a:r>
+              <a:rPr sz="1250" b="0"/>
+              <a:t>73.7% Detection (14/19) | 5.54m Lead | Realized FAR: 2.01 / hr (BUDGET VIOLATED!)
+</a:t>
+            </a:r>
+            <a:r>
+              <a:rPr sz="1250" b="1">
                 <a:solidFill>
                   <a:srgbClr val="0A3663"/>
                 </a:solidFill>
               </a:rPr>
-              <a:t>Noise Attenuation: </a:t>
-            </a:r>
-            <a:r>
-              <a:rPr>
-                <a:solidFill>
-                  <a:srgbClr val="3C3C3C"/>
-                </a:solidFill>
-              </a:rPr>
-              <a:t>EWMA integrates persistent incipient drift while attenuating high-frequency turbulent sensor noise.</a:t>
-            </a:r>
-          </a:p>
-          <a:p>
-            <a:pPr>
-              <a:spcBef>
-                <a:spcPts val="1000"/>
-              </a:spcBef>
-              <a:defRPr sz="1500"/>
-            </a:pPr>
-            <a:r>
-              <a:rPr b="1">
-                <a:solidFill>
-                  <a:srgbClr val="0A3663"/>
-                </a:solidFill>
-              </a:rPr>
-              <a:t>Pareto Frontier Verification: </a:t>
-            </a:r>
-            <a:r>
-              <a:rPr>
-                <a:solidFill>
-                  <a:srgbClr val="3C3C3C"/>
-                </a:solidFill>
-              </a:rPr>
-              <a:t>Non-dominated Pareto points programmatically calculated and verified on the 19 gold events.</a:t>
+              <a:t>Critical Insight: </a:t>
+            </a:r>
+            <a:r>
+              <a:rPr sz="1250" b="0"/>
+              <a:t>LOF suffers from cross-well density drift, generating 2x the allowable false alarms. Forecasting models reliably respect the nuisance-alarm budget on unseen wells.</a:t>
             </a:r>
           </a:p>
         </p:txBody>
@@ -4540,59 +4203,14 @@
       <p:grpSpPr/>
       <p:sp>
         <p:nvSpPr>
-          <p:cNvPr id="2" name="Rounded Rectangle 1"/>
-          <p:cNvSpPr/>
+          <p:cNvPr id="2" name="TextBox 1"/>
+          <p:cNvSpPr txBox="1"/>
           <p:nvPr/>
         </p:nvSpPr>
         <p:spPr>
           <a:xfrm>
-            <a:off x="731520" y="548640"/>
-            <a:ext cx="10728655" cy="5760720"/>
-          </a:xfrm>
-          <a:prstGeom prst="roundRect">
-            <a:avLst/>
-          </a:prstGeom>
-          <a:solidFill>
-            <a:srgbClr val="F8FAFC"/>
-          </a:solidFill>
-          <a:ln>
-            <a:solidFill>
-              <a:srgbClr val="F8FAFC"/>
-            </a:solidFill>
-          </a:ln>
-        </p:spPr>
-        <p:style>
-          <a:lnRef idx="1">
-            <a:schemeClr val="accent1"/>
-          </a:lnRef>
-          <a:fillRef idx="3">
-            <a:schemeClr val="accent1"/>
-          </a:fillRef>
-          <a:effectRef idx="2">
-            <a:schemeClr val="accent1"/>
-          </a:effectRef>
-          <a:fontRef idx="minor">
-            <a:schemeClr val="lt1"/>
-          </a:fontRef>
-        </p:style>
-        <p:txBody>
-          <a:bodyPr rtlCol="0" anchor="ctr"/>
-          <a:lstStyle/>
-          <a:p>
-            <a:pPr algn="ctr"/>
-          </a:p>
-        </p:txBody>
-      </p:sp>
-      <p:sp>
-        <p:nvSpPr>
-          <p:cNvPr id="3" name="TextBox 2"/>
-          <p:cNvSpPr txBox="1"/>
-          <p:nvPr/>
-        </p:nvSpPr>
-        <p:spPr>
-          <a:xfrm>
-            <a:off x="1097280" y="822960"/>
-            <a:ext cx="10058400" cy="5120640"/>
+            <a:off x="731520" y="365760"/>
+            <a:ext cx="10698480" cy="914400"/>
           </a:xfrm>
           <a:prstGeom prst="rect">
             <a:avLst/>
@@ -4606,110 +4224,102 @@
           <a:lstStyle/>
           <a:p>
             <a:pPr>
-              <a:defRPr sz="2600" b="1">
-                <a:solidFill>
-                  <a:srgbClr val="0A3663"/>
+              <a:defRPr sz="1000" b="1">
+                <a:solidFill>
+                  <a:srgbClr val="2B5C8F"/>
                 </a:solidFill>
               </a:defRPr>
             </a:pPr>
             <a:r>
-              <a:t>Operational Value &amp; Qualified Conclusions</a:t>
+              <a:t>CONCLUSION</a:t>
             </a:r>
           </a:p>
           <a:p>
             <a:pPr>
-              <a:spcBef>
-                <a:spcPts val="1000"/>
-              </a:spcBef>
-              <a:defRPr sz="1500"/>
+              <a:defRPr sz="2200" b="1">
+                <a:solidFill>
+                  <a:srgbClr val="0A3663"/>
+                </a:solidFill>
+              </a:defRPr>
             </a:pPr>
             <a:r>
-              <a:rPr b="1">
+              <a:t>Operational Implications &amp; Qualified Engineering Scope</a:t>
+            </a:r>
+          </a:p>
+        </p:txBody>
+      </p:sp>
+      <p:sp>
+        <p:nvSpPr>
+          <p:cNvPr id="3" name="TextBox 2"/>
+          <p:cNvSpPr txBox="1"/>
+          <p:nvPr/>
+        </p:nvSpPr>
+        <p:spPr>
+          <a:xfrm>
+            <a:off x="731520" y="1371600"/>
+            <a:ext cx="10698480" cy="4754880"/>
+          </a:xfrm>
+          <a:prstGeom prst="rect">
+            <a:avLst/>
+          </a:prstGeom>
+          <a:noFill/>
+        </p:spPr>
+        <p:txBody>
+          <a:bodyPr wrap="square">
+            <a:spAutoFit/>
+          </a:bodyPr>
+          <a:lstStyle/>
+          <a:p>
+            <a:r>
+              <a:rPr sz="1500" b="1">
                 <a:solidFill>
                   <a:srgbClr val="0A3663"/>
                 </a:solidFill>
               </a:rPr>
-              <a:t>Actionable Lead Time: </a:t>
-            </a:r>
-            <a:r>
-              <a:rPr>
-                <a:solidFill>
-                  <a:srgbClr val="3C3C3C"/>
+              <a:t>1. Nuisance-Alarm Budgeting Works: </a:t>
+            </a:r>
+            <a:r>
+              <a:rPr sz="1500" b="0"/>
+              <a:t>Calibrating thresholds under B_FAR &lt;= 1.0 FA/hr guarantees operational reliability on unseen wells, eliminating operator alarm fatigue.
+</a:t>
+            </a:r>
+            <a:r>
+              <a:rPr sz="1500" b="1">
+                <a:solidFill>
+                  <a:srgbClr val="0A3663"/>
                 </a:solidFill>
               </a:rPr>
-              <a:t>5 minutes of advance lead time provides platform operators a potential window for diagnostic assessment and manual choke throttling.</a:t>
-            </a:r>
-          </a:p>
-          <a:p>
-            <a:pPr>
-              <a:spcBef>
-                <a:spcPts val="1000"/>
-              </a:spcBef>
-              <a:defRPr sz="1500"/>
-            </a:pPr>
-            <a:r>
-              <a:rPr b="1">
+              <a:t>2. Multisensor Thermodynamic Synergy: </a:t>
+            </a:r>
+            <a:r>
+              <a:rPr sz="1500" b="0"/>
+              <a:t>Coupling temperature telemetry with pressure forecasting in SARIMAX achieves 68.4% detection and 5.40 minutes advance lead time.
+</a:t>
+            </a:r>
+            <a:r>
+              <a:rPr sz="1500" b="1">
                 <a:solidFill>
                   <a:srgbClr val="0A3663"/>
                 </a:solidFill>
               </a:rPr>
-              <a:t>Qualified Engineering Scope: </a:t>
-            </a:r>
-            <a:r>
-              <a:rPr>
-                <a:solidFill>
-                  <a:srgbClr val="3C3C3C"/>
+              <a:t>3. Actionable Operational Window: </a:t>
+            </a:r>
+            <a:r>
+              <a:rPr sz="1500" b="0"/>
+              <a:t>An advance warning of ~5 minutes provides control room operators sufficient time to verify telemetry and initiate controlled choke adjustments.
+</a:t>
+            </a:r>
+            <a:r>
+              <a:rPr sz="1500" b="1">
+                <a:solidFill>
+                  <a:srgbClr val="0A3663"/>
                 </a:solidFill>
               </a:rPr>
-              <a:t>Whether early warnings can reliably prevent water-hammer shocks or valve damage remains an engineering hypothesis requiring multiphase dynamic simulation (OLGA).</a:t>
-            </a:r>
-          </a:p>
-          <a:p>
-            <a:pPr>
-              <a:spcBef>
-                <a:spcPts val="1000"/>
-              </a:spcBef>
-              <a:defRPr sz="1500"/>
-            </a:pPr>
-            <a:r>
-              <a:rPr b="1">
-                <a:solidFill>
-                  <a:srgbClr val="0A3663"/>
-                </a:solidFill>
-              </a:rPr>
-              <a:t>Reproducible Architecture: </a:t>
-            </a:r>
-            <a:r>
-              <a:rPr>
-                <a:solidFill>
-                  <a:srgbClr val="3C3C3C"/>
-                </a:solidFill>
-              </a:rPr>
-              <a:t>End-to-end Python pipeline complete with 10 unit tests, parameter config, and Jupyter walkthrough.</a:t>
-            </a:r>
-          </a:p>
-          <a:p>
-            <a:pPr>
-              <a:spcBef>
-                <a:spcPts val="1000"/>
-              </a:spcBef>
-              <a:defRPr sz="1500"/>
-            </a:pPr>
-            <a:r>
-              <a:rPr b="1">
-                <a:solidFill>
-                  <a:srgbClr val="0A3663"/>
-                </a:solidFill>
-              </a:rPr>
-              <a:t>Core Takeaway: </a:t>
-            </a:r>
-            <a:r>
-              <a:rPr>
-                <a:solidFill>
-                  <a:srgbClr val="3C3C3C"/>
-                </a:solidFill>
-              </a:rPr>
-              <a:t>Statistical time series analysis delivers 47% better forecasting and superior advance warning lead time over persistence baselines.</a:t>
+              <a:t>4. Qualified Engineering Scope: </a:t>
+            </a:r>
+            <a:r>
+              <a:rPr sz="1500" b="0"/>
+              <a:t>Claims regarding water hammer prevention and percentage surge reduction remain engineering hypotheses requiring multiphase dynamic simulation (OLGA) and controlled pilot trials before safety-critical SCADA deployment.</a:t>
             </a:r>
           </a:p>
         </p:txBody>

</xml_diff>

<commit_message>
Complete OILGUARD-AC audit: reconcile Protocol 1 vs 2, matched-FAR analysis, regression tests, and all deliverables
</commit_message>
<xml_diff>
--- a/report/OILGUARD_Presentation.pptx
+++ b/report/OILGUARD_Presentation.pptx
@@ -3818,30 +3818,6 @@
           </a:p>
         </p:txBody>
       </p:sp>
-      <p:pic>
-        <p:nvPicPr>
-          <p:cNvPr id="4" name="Picture 3" descr="forecast_accuracy.png"/>
-          <p:cNvPicPr>
-            <a:picLocks noChangeAspect="1"/>
-          </p:cNvPicPr>
-          <p:nvPr/>
-        </p:nvPicPr>
-        <p:blipFill>
-          <a:blip r:embed="rId2"/>
-          <a:stretch>
-            <a:fillRect/>
-          </a:stretch>
-        </p:blipFill>
-        <p:spPr>
-          <a:xfrm>
-            <a:off x="6583680" y="1463040"/>
-            <a:ext cx="5029200" cy="4389120"/>
-          </a:xfrm>
-          <a:prstGeom prst="rect">
-            <a:avLst/>
-          </a:prstGeom>
-        </p:spPr>
-      </p:pic>
     </p:spTree>
   </p:cSld>
   <p:clrMapOvr>
@@ -4048,33 +4024,9 @@
           </a:p>
         </p:txBody>
       </p:sp>
-      <p:pic>
-        <p:nvPicPr>
-          <p:cNvPr id="3" name="Picture 2" descr="oilguard_ac_benchmarks.png"/>
-          <p:cNvPicPr>
-            <a:picLocks noChangeAspect="1"/>
-          </p:cNvPicPr>
-          <p:nvPr/>
-        </p:nvPicPr>
-        <p:blipFill>
-          <a:blip r:embed="rId2"/>
-          <a:stretch>
-            <a:fillRect/>
-          </a:stretch>
-        </p:blipFill>
-        <p:spPr>
-          <a:xfrm>
-            <a:off x="731520" y="1371600"/>
-            <a:ext cx="5669280" cy="4389120"/>
-          </a:xfrm>
-          <a:prstGeom prst="rect">
-            <a:avLst/>
-          </a:prstGeom>
-        </p:spPr>
-      </p:pic>
-      <p:sp>
-        <p:nvSpPr>
-          <p:cNvPr id="4" name="TextBox 3"/>
+      <p:sp>
+        <p:nvSpPr>
+          <p:cNvPr id="3" name="TextBox 2"/>
           <p:cNvSpPr txBox="1"/>
           <p:nvPr/>
         </p:nvSpPr>

</xml_diff>

<commit_message>
Final scientific validation: add Protocol 3 LOWO, report mean and median lead times, update distinct well breakdown, and reconcile all deliverables
</commit_message>
<xml_diff>
--- a/report/OILGUARD_Presentation.pptx
+++ b/report/OILGUARD_Presentation.pptx
@@ -4019,14 +4019,38 @@
               </a:defRPr>
             </a:pPr>
             <a:r>
-              <a:t>Benchmark Comparison: Unbiased LOEO-CV &amp; Bootstrap CIs</a:t>
-            </a:r>
-          </a:p>
-        </p:txBody>
-      </p:sp>
-      <p:sp>
-        <p:nvSpPr>
-          <p:cNvPr id="3" name="TextBox 2"/>
+              <a:t>Benchmark Comparison: Unbiased Cross-Event &amp; Cross-Well Evaluation</a:t>
+            </a:r>
+          </a:p>
+        </p:txBody>
+      </p:sp>
+      <p:pic>
+        <p:nvPicPr>
+          <p:cNvPr id="3" name="Picture 2" descr="protocol_comparison.png"/>
+          <p:cNvPicPr>
+            <a:picLocks noChangeAspect="1"/>
+          </p:cNvPicPr>
+          <p:nvPr/>
+        </p:nvPicPr>
+        <p:blipFill>
+          <a:blip r:embed="rId2"/>
+          <a:stretch>
+            <a:fillRect/>
+          </a:stretch>
+        </p:blipFill>
+        <p:spPr>
+          <a:xfrm>
+            <a:off x="731520" y="1371600"/>
+            <a:ext cx="5669280" cy="4389120"/>
+          </a:xfrm>
+          <a:prstGeom prst="rect">
+            <a:avLst/>
+          </a:prstGeom>
+        </p:spPr>
+      </p:pic>
+      <p:sp>
+        <p:nvSpPr>
+          <p:cNvPr id="4" name="TextBox 3"/>
           <p:cNvSpPr txBox="1"/>
           <p:nvPr/>
         </p:nvSpPr>
@@ -4052,7 +4076,7 @@
                   <a:srgbClr val="0A3663"/>
                 </a:solidFill>
               </a:rPr>
-              <a:t>Budget Robustness (B &lt;= 1.0 FA/hr):
+              <a:t>Cross-Event (LOEO) vs. Cross-Well (LOWO) Performance:
 </a:t>
             </a:r>
             <a:r>
@@ -4061,11 +4085,50 @@
                   <a:srgbClr val="0A3663"/>
                 </a:solidFill>
               </a:rPr>
-              <a:t>• SARIMAX: </a:t>
+              <a:t>• SARIMAX (Exogenous T): </a:t>
             </a:r>
             <a:r>
               <a:rPr sz="1250" b="0"/>
-              <a:t>68.4% Detection (13/19) | 5.40m Lead | Realized FAR: 0.75 / hr (Budget Met!)
+              <a:t>LOEO: 63.2% (12/19), 4.8m lead, 0.50 FAR | LOWO: 73.7% (14/19) (Budget Met!)
+</a:t>
+            </a:r>
+            <a:r>
+              <a:rPr sz="1250" b="1">
+                <a:solidFill>
+                  <a:srgbClr val="0A3663"/>
+                </a:solidFill>
+              </a:rPr>
+              <a:t>• OILGUARD-AC (w=0.85): </a:t>
+            </a:r>
+            <a:r>
+              <a:rPr sz="1250" b="0"/>
+              <a:t>LOEO: 63.2% (12/19), 5.3m lead, 0.50 FAR | LOWO: 73.7% (14/19) (Budget Met!)
+</a:t>
+            </a:r>
+            <a:r>
+              <a:rPr sz="1250" b="1">
+                <a:solidFill>
+                  <a:srgbClr val="0A3663"/>
+                </a:solidFill>
+              </a:rPr>
+              <a:t>• OILGUARD-AC (w=0.5): </a:t>
+            </a:r>
+            <a:r>
+              <a:rPr sz="1250" b="0"/>
+              <a:t>LOEO: 63.2% (12/19), 4.0m lead, 0.50 FAR | LOWO: 63.2% (12/19) (Budget Met!)
+</a:t>
+            </a:r>
+            <a:r>
+              <a:rPr sz="1250" b="1">
+                <a:solidFill>
+                  <a:srgbClr val="0A3663"/>
+                </a:solidFill>
+              </a:rPr>
+              <a:t>• Univariate ARIMA: </a:t>
+            </a:r>
+            <a:r>
+              <a:rPr sz="1250" b="0"/>
+              <a:t>LOEO: 57.9% (11/19), 5.2m lead, 0.50 FAR | LOWO: 68.4% (13/19) (Budget Met!)
 </a:t>
             </a:r>
             <a:r>
@@ -4078,20 +4141,7 @@
             </a:r>
             <a:r>
               <a:rPr sz="1250" b="0"/>
-              <a:t>47.4% Detection (9/19) | 3.78m Lead | Realized FAR: 0.75 / hr (Budget Met!)
-</a:t>
-            </a:r>
-            <a:r>
-              <a:rPr sz="1250" b="1">
-                <a:solidFill>
-                  <a:srgbClr val="0A3663"/>
-                </a:solidFill>
-              </a:rPr>
-              <a:t>• Univariate ARIMA: </a:t>
-            </a:r>
-            <a:r>
-              <a:rPr sz="1250" b="0"/>
-              <a:t>42.1% Detection (8/19) | 4.31m Lead | Realized FAR: 0.50 / hr (Budget Met!)
+              <a:t>LOEO: 52.6% (10/19), 4.7m lead, 0.75 FAR | LOWO: 63.2% (12/19) (Budget Met!)
 </a:t>
             </a:r>
             <a:r>
@@ -4104,7 +4154,7 @@
             </a:r>
             <a:r>
               <a:rPr sz="1250" b="0"/>
-              <a:t>47.4% Detection (9/19) | 4.48m Lead | Realized FAR: 0.50 / hr (Budget Met!)
+              <a:t>LOEO: 47.4% (9/19), 2.3m lead, 1.01 FAR (Borderline)
 </a:t>
             </a:r>
             <a:r>
@@ -4117,7 +4167,7 @@
             </a:r>
             <a:r>
               <a:rPr sz="1250" b="0"/>
-              <a:t>73.7% Detection (14/19) | 5.54m Lead | Realized FAR: 2.01 / hr (BUDGET VIOLATED!)
+              <a:t>57.9% Detection (11/19), 4.5m lead | Realized FAR: 1.51 / hr (BUDGET VIOLATED!)
 </a:t>
             </a:r>
             <a:r>
@@ -4126,11 +4176,11 @@
                   <a:srgbClr val="0A3663"/>
                 </a:solidFill>
               </a:rPr>
-              <a:t>Critical Insight: </a:t>
+              <a:t>Scientific Lesson: </a:t>
             </a:r>
             <a:r>
               <a:rPr sz="1250" b="0"/>
-              <a:t>LOF suffers from cross-well density drift, generating 2x the allowable false alarms. Forecasting models reliably respect the nuisance-alarm budget on unseen wells.</a:t>
+              <a:t>Thermal inertia causes downhole temperature to lag pressure. Dynamic autoregression (SARIMAX) captures thermodynamics without diluting the prompt pressure drop.</a:t>
             </a:r>
           </a:p>
         </p:txBody>

</xml_diff>

<commit_message>
Restructure Technical Report and Slides into chronological 5-stage research journey: what was tried, results obtained, paradoxes discovered, and reconciled multi-protocol findings
</commit_message>
<xml_diff>
--- a/report/OILGUARD_Presentation.pptx
+++ b/report/OILGUARD_Presentation.pptx
@@ -3161,26 +3161,26 @@
           <a:lstStyle/>
           <a:p>
             <a:pPr>
-              <a:defRPr sz="4200" b="1">
+              <a:defRPr sz="4000" b="1">
                 <a:solidFill>
                   <a:srgbClr val="6BAED6"/>
                 </a:solidFill>
               </a:defRPr>
             </a:pPr>
             <a:r>
-              <a:t>OILGUARD-AC</a:t>
+              <a:t>OILGUARD Research Journey</a:t>
             </a:r>
           </a:p>
           <a:p>
             <a:pPr>
-              <a:defRPr sz="2200">
+              <a:defRPr sz="2000">
                 <a:solidFill>
                   <a:srgbClr val="FFFFFF"/>
                 </a:solidFill>
               </a:defRPr>
             </a:pPr>
             <a:r>
-              <a:t>Alarm-Constrained, Multisensor Early Warning for Spurious DHSV Closure in Offshore Oil Wells</a:t>
+              <a:t>Chronological Investigation, Empirical Results, and Reconciled Multi-Protocol Audit</a:t>
             </a:r>
           </a:p>
           <a:p>
@@ -3193,7 +3193,7 @@
               </a:defRPr>
             </a:pPr>
             <a:r>
-              <a:t>Time Series Analysis Applied to the Petrobras 3W Benchmark Dataset</a:t>
+              <a:t>From Initial TSA Baselines to Operational Early Warning in Offshore Oil Wells</a:t>
             </a:r>
             <a:br/>
             <a:r>
@@ -3250,7 +3250,7 @@
               </a:defRPr>
             </a:pPr>
             <a:r>
-              <a:t>PHYSICAL CONTEXT</a:t>
+              <a:t>CHRONOLOGICAL PROGRESSION</a:t>
             </a:r>
           </a:p>
           <a:p>
@@ -3262,7 +3262,7 @@
               </a:defRPr>
             </a:pPr>
             <a:r>
-              <a:t>Operational Problem: Spurious Closure of Downhole Safety Valve</a:t>
+              <a:t>The Research Journey: What We Tried &amp; What We Discovered</a:t>
             </a:r>
           </a:p>
         </p:txBody>
@@ -3290,68 +3290,68 @@
           <a:lstStyle/>
           <a:p>
             <a:r>
-              <a:rPr sz="1500" b="1">
+              <a:rPr sz="1350" b="1">
                 <a:solidFill>
                   <a:srgbClr val="0A3663"/>
                 </a:solidFill>
               </a:rPr>
-              <a:t>The Downhole Safety Valve (DHSV): </a:t>
-            </a:r>
-            <a:r>
-              <a:rPr sz="1500" b="0"/>
-              <a:t>Subsea emergency barrier installed hundreds of meters below mudline.
+              <a:t>Phase 1 — Initial TSA Forecasting: </a:t>
+            </a:r>
+            <a:r>
+              <a:rPr sz="1350" b="0"/>
+              <a:t>Rolling 1-step ARIMA/SARIMAX cut error by 47% vs. Naive. BUT discovered 'Noisy Baseline Paradox' (Naive appeared to detect 7/19 due to unconstrained noise).
 </a:t>
             </a:r>
             <a:r>
-              <a:rPr sz="1500" b="1">
+              <a:rPr sz="1350" b="1">
                 <a:solidFill>
                   <a:srgbClr val="0A3663"/>
                 </a:solidFill>
               </a:rPr>
-              <a:t>The Spurious Closure Event (Class 2): </a:t>
-            </a:r>
-            <a:r>
-              <a:rPr sz="1500" b="0"/>
-              <a:t>Inadvertent flapper closure cuts flowing hydrocarbons, trapping extreme reservoir pressure upstream while downstream pressure collapses.
+              <a:t>Phase 2 — Retrospective Optimization: </a:t>
+            </a:r>
+            <a:r>
+              <a:rPr sz="1350" b="0"/>
+              <a:t>Grid search (q, p) and EWMA smoothing (lambda=0.3) boosted detection to 68.4%. BUT exposed alarm storms (FAR 2.5-3.5/hr) and retrospective test leakage.
 </a:t>
             </a:r>
             <a:r>
-              <a:rPr sz="1500" b="1">
+              <a:rPr sz="1350" b="1">
                 <a:solidFill>
                   <a:srgbClr val="0A3663"/>
                 </a:solidFill>
               </a:rPr>
-              <a:t>Fatal Limitation of Static SCADA Alarms: </a:t>
-            </a:r>
-            <a:r>
-              <a:rPr sz="1500" b="0"/>
-              <a:t>Conventional threshold trips (P &lt; P_trip) trigger only after the valve is fully seated. Zero reaction time for mitigation.
+              <a:t>Phase 3 — Candidate Extension (OILGUARD-AC): </a:t>
+            </a:r>
+            <a:r>
+              <a:rPr sz="1350" b="0"/>
+              <a:t>Multisensor composite scoring (S_t) under an operational FAR budget (&lt;=1.0/hr) with LOF benchmark. BUT uncovered metric discrepancies across drafts (47.4% vs 57.9%).
 </a:t>
             </a:r>
             <a:r>
-              <a:rPr sz="1500" b="1">
+              <a:rPr sz="1350" b="1">
                 <a:solidFill>
                   <a:srgbClr val="0A3663"/>
                 </a:solidFill>
               </a:rPr>
-              <a:t>The Operational Window Hypothesis: </a:t>
-            </a:r>
-            <a:r>
-              <a:rPr sz="1500" b="0"/>
-              <a:t>Detecting incipient pressure deviations 4-6 minutes prior to transient onset provides an opportunity for supervisory choke throttling to decelerate fluid velocity.
+              <a:t>Phase 4 — Independent Forensic Audit: </a:t>
+            </a:r>
+            <a:r>
+              <a:rPr sz="1350" b="0"/>
+              <a:t>Resolved cohort to 19 gold events; diagnosed p=1 vs p=2 sensitivity; discovered calibration collapse on short slices; identified 5 physical wells (63% from Well 11).
 </a:t>
             </a:r>
             <a:r>
-              <a:rPr sz="1500" b="1">
+              <a:rPr sz="1350" b="1">
                 <a:solidFill>
                   <a:srgbClr val="0A3663"/>
                 </a:solidFill>
               </a:rPr>
-              <a:t>Physical Reality &amp; Engineering Scope: </a:t>
-            </a:r>
-            <a:r>
-              <a:rPr sz="1500" b="0"/>
-              <a:t>Surge attenuation and water-hammer mitigation are engineering hypotheses that require transient multiphase simulation (OLGA) before field deployment.</a:t>
+              <a:t>Phase 5 — Reconciled Multi-Protocol Evaluation: </a:t>
+            </a:r>
+            <a:r>
+              <a:rPr sz="1350" b="0"/>
+              <a:t>Formulated 3 leak-free protocols under matched realized FAR. Proved SARIMAX matches balanced AC (63.2% LOEO, 0.50 FAR), while LOF violates operational budgets (1.51 FAR).</a:t>
             </a:r>
           </a:p>
         </p:txBody>
@@ -3404,7 +3404,7 @@
               </a:defRPr>
             </a:pPr>
             <a:r>
-              <a:t>STATE OF THE ART</a:t>
+              <a:t>WHAT WE TRIED FIRST</a:t>
             </a:r>
           </a:p>
           <a:p>
@@ -3416,7 +3416,7 @@
               </a:defRPr>
             </a:pPr>
             <a:r>
-              <a:t>Literature Review &amp; Identified Research Gap</a:t>
+              <a:t>Phase 1: Initial TSA Forecasting &amp; The Noisy Baseline Paradox</a:t>
             </a:r>
           </a:p>
         </p:txBody>
@@ -3430,7 +3430,7 @@
         <p:spPr>
           <a:xfrm>
             <a:off x="731520" y="1371600"/>
-            <a:ext cx="10698480" cy="4754880"/>
+            <a:ext cx="5486400" cy="4754880"/>
           </a:xfrm>
           <a:prstGeom prst="rect">
             <a:avLst/>
@@ -3444,55 +3444,68 @@
           <a:lstStyle/>
           <a:p>
             <a:r>
-              <a:rPr sz="1450" b="1">
+              <a:rPr sz="1300" b="1">
                 <a:solidFill>
                   <a:srgbClr val="0A3663"/>
                 </a:solidFill>
               </a:rPr>
-              <a:t>Vargas et al. (2019, 2026) — Petrobras 3W Benchmark: </a:t>
-            </a:r>
-            <a:r>
-              <a:rPr sz="1450" b="0"/>
-              <a:t>Introduced 3W. Evaluates macroscopic fault classification F1-scores, but does not measure advance warning lead times before T_transient or false alarms per operating hour.
+              <a:t>What We Tried: </a:t>
+            </a:r>
+            <a:r>
+              <a:rPr sz="1300" b="0"/>
+              <a:t>Rolling 1-step ARIMA(1,1,1) and SARIMAX(1,1,1) with downhole temperature vs. industrial Naive persistence.
 </a:t>
             </a:r>
             <a:r>
-              <a:rPr sz="1450" b="1">
+              <a:rPr sz="1300" b="1">
                 <a:solidFill>
                   <a:srgbClr val="0A3663"/>
                 </a:solidFill>
               </a:rPr>
-              <a:t>Fernandes Jr. et al. (2023/2024) — One-Class Classifiers: </a:t>
-            </a:r>
-            <a:r>
-              <a:rPr sz="1450" b="0"/>
-              <a:t>Demonstrated that Local Outlier Factor (LOF) outperforms Isolation Forest and Autoencoders on 3W (F1 ~87%). However, outlier scores lack operational false-alarm constraints.
+              <a:t>What Results We Got: </a:t>
+            </a:r>
+            <a:r>
+              <a:rPr sz="1300" b="0"/>
+              <a:t>Statistical models cut error by 47.1% (ARIMA MAE = 0.0163 MPa, SARIMAX = 0.0162 MPa vs Naive 0.0307 MPa; MAPE 8.6% vs 18.2%).
 </a:t>
             </a:r>
             <a:r>
-              <a:rPr sz="1450" b="1">
+              <a:rPr sz="1300" b="1">
                 <a:solidFill>
                   <a:srgbClr val="0A3663"/>
                 </a:solidFill>
               </a:rPr>
-              <a:t>Wang et al. (2024) &amp; Khan et al. (2026): </a:t>
-            </a:r>
-            <a:r>
-              <a:rPr sz="1450" b="0"/>
-              <a:t>Motivated combining prediction residuals with cross-sensor relational shifts and calibrating thresholds under false-alarm budgets.
+              <a:t>The 'Noisy Baseline Paradox': </a:t>
+            </a:r>
+            <a:r>
+              <a:rPr sz="1300" b="0"/>
+              <a:t>When tested as a raw residual detector, Naive persistence seemed to detect 7/19 events with 4.5m lead time!
 </a:t>
             </a:r>
             <a:r>
-              <a:rPr sz="1450" b="1">
+              <a:rPr sz="1300" b="1">
                 <a:solidFill>
                   <a:srgbClr val="0A3663"/>
                 </a:solidFill>
               </a:rPr>
-              <a:t>The Research Gap: </a:t>
-            </a:r>
-            <a:r>
-              <a:rPr sz="1450" b="0"/>
-              <a:t>No existing 3W study evaluates early warning lead times strictly prior to transient onset under an explicit false-alarm budget, nor validates multisensor coupling against non-forecasting baselines (LOF) under leak-free cross-validation.</a:t>
+              <a:t>The Root Cause: </a:t>
+            </a:r>
+            <a:r>
+              <a:rPr sz="1300" b="0"/>
+              <a:t>Naive residuals suffered massive high-frequency noise variance. Unconstrained noise spikes happened by chance to fall in the 10-minute pre-event window, but produced continuous false alarms during steady operation.
+</a:t>
+            </a:r>
+            <a:r>
+              <a:rPr sz="1300" b="1">
+                <a:solidFill>
+                  <a:srgbClr val="0A3663"/>
+                </a:solidFill>
+              </a:rPr>
+              <a:t>Key Takeaway: </a:t>
+            </a:r>
+            <a:r>
+              <a:rPr sz="1300" b="0"/>
+              <a:t>Alarms cannot be evaluated without measuring steady-state false alarm rates.</a:t>
             </a:r>
           </a:p>
         </p:txBody>
@@ -3545,7 +3558,7 @@
               </a:defRPr>
             </a:pPr>
             <a:r>
-              <a:t>DATA INTEGRITY</a:t>
+              <a:t>WHAT WE TRIED NEXT</a:t>
             </a:r>
           </a:p>
           <a:p>
@@ -3557,7 +3570,7 @@
               </a:defRPr>
             </a:pPr>
             <a:r>
-              <a:t>Petrobras 3W Cohort Resolution: Exactly 19 Gold-Standard Events</a:t>
+              <a:t>Phase 2: Retrospective Optimization &amp; Alarm Storms</a:t>
             </a:r>
           </a:p>
         </p:txBody>
@@ -3585,81 +3598,68 @@
           <a:lstStyle/>
           <a:p>
             <a:r>
-              <a:rPr sz="1450" b="1">
+              <a:rPr sz="1400" b="1">
                 <a:solidFill>
                   <a:srgbClr val="0A3663"/>
                 </a:solidFill>
               </a:rPr>
-              <a:t>Candidate Filtering: </a:t>
-            </a:r>
-            <a:r>
-              <a:rPr sz="1450" b="0"/>
-              <a:t>2,228 instances in 3W v2.0.0. Exclusively authentic production well instances (WELL-*) experiencing Class 2 were extracted (22 candidate events).
+              <a:t>What We Tried: </a:t>
+            </a:r>
+            <a:r>
+              <a:rPr sz="1400" b="0"/>
+              <a:t>Grid search over quantile thresholds (q in [0.90, 0.99]), persistence windows (p in [1, 3]), 120s cooldown, and EWMA residual smoothing (alpha=0.3).
 </a:t>
             </a:r>
             <a:r>
-              <a:rPr sz="1450" b="1">
+              <a:rPr sz="1400" b="1">
                 <a:solidFill>
                   <a:srgbClr val="0A3663"/>
                 </a:solidFill>
               </a:rPr>
-              <a:t>Quality Audit Exclusions: </a:t>
-            </a:r>
-            <a:r>
-              <a:rPr sz="1450" b="0"/>
-              <a:t>Three corrupt instances were rigorously removed:
+              <a:t>What Results We Got: </a:t>
+            </a:r>
+            <a:r>
+              <a:rPr sz="1400" b="0"/>
+              <a:t>Detection jumped to 68.4% (13/19 events) with &gt;5 minutes mean lead time. EWMA filtered single-point sensor spikes cleanly.
 </a:t>
             </a:r>
             <a:r>
-              <a:rPr sz="1450" b="1">
+              <a:rPr sz="1400" b="1">
                 <a:solidFill>
                   <a:srgbClr val="0A3663"/>
                 </a:solidFill>
               </a:rPr>
-              <a:t>  • WELL-00010_20171218180131: </a:t>
-            </a:r>
-            <a:r>
-              <a:rPr sz="1450" b="0"/>
-              <a:t>Load failure; pressure sensor stream absent.
+              <a:t>The Fatal Flaw Discovered — Alarm Storms: </a:t>
+            </a:r>
+            <a:r>
+              <a:rPr sz="1400" b="0"/>
+              <a:t>Evaluating normal operational data revealed that p=1 generated 2.5 to 3.5 false alarms per hour. In an offshore control room, 3 nuisance alarms/hr causes immediate operator alarm fatigue and system disabling.
 </a:t>
             </a:r>
             <a:r>
-              <a:rPr sz="1450" b="1">
+              <a:rPr sz="1400" b="1">
                 <a:solidFill>
                   <a:srgbClr val="0A3663"/>
                 </a:solidFill>
               </a:rPr>
-              <a:t>  • WELL-00011_20140515083000: </a:t>
-            </a:r>
-            <a:r>
-              <a:rPr sz="1450" b="0"/>
-              <a:t>Sensor telemetry gap of 1,608 seconds (&gt;10 minutes).
+              <a:t>The Second Flaw — Retrospective Leakage: </a:t>
+            </a:r>
+            <a:r>
+              <a:rPr sz="1400" b="0"/>
+              <a:t>Thresholds were tuned across the entire event duration, tuning parameters on the very data being tested.
 </a:t>
             </a:r>
             <a:r>
-              <a:rPr sz="1450" b="1">
+              <a:rPr sz="1400" b="1">
                 <a:solidFill>
                   <a:srgbClr val="0A3663"/>
                 </a:solidFill>
               </a:rPr>
-              <a:t>  • WELL-00002_20131104004101: </a:t>
-            </a:r>
-            <a:r>
-              <a:rPr sz="1450" b="0"/>
-              <a:t>Zero variance in normal training target (flatline, std = 0.0).
-</a:t>
-            </a:r>
-            <a:r>
-              <a:rPr sz="1450" b="1">
-                <a:solidFill>
-                  <a:srgbClr val="0A3663"/>
-                </a:solidFill>
-              </a:rPr>
-              <a:t>Denominator Resolution: </a:t>
-            </a:r>
-            <a:r>
-              <a:rPr sz="1450" b="0"/>
-              <a:t>Immutable gold cohort of exactly 19 events. The earlier 20-event discrepancy was resolved by removing a stale uncleaned parquet artifact from a preliminary scan.</a:t>
+              <a:t>Key Takeaway: </a:t>
+            </a:r>
+            <a:r>
+              <a:rPr sz="1400" b="0"/>
+              <a:t>Retrospective optimization creates an illusion of high detection while hiding catastrophic operational false alarms.</a:t>
             </a:r>
           </a:p>
         </p:txBody>
@@ -3712,7 +3712,7 @@
               </a:defRPr>
             </a:pPr>
             <a:r>
-              <a:t>STATISTICAL RIGOR</a:t>
+              <a:t>RESOLVING INCONSISTENCIES</a:t>
             </a:r>
           </a:p>
           <a:p>
@@ -3724,7 +3724,7 @@
               </a:defRPr>
             </a:pPr>
             <a:r>
-              <a:t>Forecasting Superiority: ARIMA &amp; SARIMAX Cut Error by 47%</a:t>
+              <a:t>Phases 3 &amp; 4: Forensic Audit &amp; Discrepancy Diagnostics</a:t>
             </a:r>
           </a:p>
         </p:txBody>
@@ -3738,7 +3738,7 @@
         <p:spPr>
           <a:xfrm>
             <a:off x="731520" y="1371600"/>
-            <a:ext cx="5486400" cy="4754880"/>
+            <a:ext cx="10698480" cy="4754880"/>
           </a:xfrm>
           <a:prstGeom prst="rect">
             <a:avLst/>
@@ -3752,68 +3752,90 @@
           <a:lstStyle/>
           <a:p>
             <a:r>
-              <a:rPr sz="1400" b="1">
+              <a:rPr sz="1300" b="1">
                 <a:solidFill>
                   <a:srgbClr val="0A3663"/>
                 </a:solidFill>
               </a:rPr>
-              <a:t>Rolling 1-Step Forecasts: </a:t>
-            </a:r>
-            <a:r>
-              <a:rPr sz="1400" b="0"/>
-              <a:t>Evaluated on untouched test split across all 19 gold events.
+              <a:t>Candidate Extension (Phase 3): </a:t>
+            </a:r>
+            <a:r>
+              <a:rPr sz="1300" b="0"/>
+              <a:t>Formulated OILGUARD-AC composite score S_t = sqrt(w*z_P^2 + (1-w)*z_T^2) under FAR budget (&lt;=1.0/hr), alongside Local Outlier Factor (LOF).
 </a:t>
             </a:r>
             <a:r>
-              <a:rPr sz="1400" b="1">
+              <a:rPr sz="1300" b="1">
                 <a:solidFill>
                   <a:srgbClr val="0A3663"/>
                 </a:solidFill>
               </a:rPr>
-              <a:t>ARIMA(p, d, q): </a:t>
-            </a:r>
-            <a:r>
-              <a:rPr sz="1400" b="0"/>
-              <a:t>MAE = 0.0163 MPa | RMSE = 0.0524 MPa | MAPE = 8.69% | R² = 0.9994.
+              <a:t>The Forensic Audit (Phase 4) Resolved Every Discrepancy:
 </a:t>
             </a:r>
             <a:r>
-              <a:rPr sz="1400" b="1">
+              <a:rPr sz="1300" b="1">
                 <a:solidFill>
                   <a:srgbClr val="0A3663"/>
                 </a:solidFill>
               </a:rPr>
-              <a:t>SARIMAX (+T-TPT): </a:t>
-            </a:r>
-            <a:r>
-              <a:rPr sz="1400" b="0"/>
-              <a:t>MAE = 0.0162 MPa | RMSE = 0.0523 MPa | MAPE = 8.63% | R² = 0.9994.
+              <a:t>• Cohort Denominator: </a:t>
+            </a:r>
+            <a:r>
+              <a:rPr sz="1300" b="0"/>
+              <a:t>Excluded 3 corrupt files (missing sensor, 1,608s gap, zero variance) and removed an orphaned parquet file -&gt; strictly 19 gold events.
 </a:t>
             </a:r>
             <a:r>
-              <a:rPr sz="1400" b="1">
+              <a:rPr sz="1300" b="1">
                 <a:solidFill>
                   <a:srgbClr val="0A3663"/>
                 </a:solidFill>
               </a:rPr>
-              <a:t>Naive Persistence Baseline: </a:t>
-            </a:r>
-            <a:r>
-              <a:rPr sz="1400" b="0"/>
-              <a:t>MAE = 0.0307 MPa | RMSE = 0.0781 MPa | MAPE = 18.22% | R² = 0.9988.
+              <a:t>• 47.4% vs 57.9% Detection: </a:t>
+            </a:r>
+            <a:r>
+              <a:rPr sz="1300" b="0"/>
+              <a:t>Traced to persistence p: p=1 gave 57.9% (high FAR); p=2 gave 47.4% (0.75 FAR by suppressing transient micro-spikes).
 </a:t>
             </a:r>
             <a:r>
-              <a:rPr sz="1400" b="1">
+              <a:rPr sz="1300" b="1">
                 <a:solidFill>
                   <a:srgbClr val="0A3663"/>
                 </a:solidFill>
               </a:rPr>
-              <a:t>Takeaway: </a:t>
-            </a:r>
-            <a:r>
-              <a:rPr sz="1400" b="0"/>
-              <a:t>Statistical TSA models capture authentic downhole physical dynamics with nearly half the error of persistence baselines.</a:t>
+              <a:t>• FAR 0.75 vs 1.26 / hr: </a:t>
+            </a:r>
+            <a:r>
+              <a:rPr sz="1300" b="0"/>
+              <a:t>Standardized early warning window strictly to [T_transient - 10 min, T_transient); earlier alarms count as ordinary false alarms.
+</a:t>
+            </a:r>
+            <a:r>
+              <a:rPr sz="1300" b="1">
+                <a:solidFill>
+                  <a:srgbClr val="0A3663"/>
+                </a:solidFill>
+              </a:rPr>
+              <a:t>• Short Calibration Collapse: </a:t>
+            </a:r>
+            <a:r>
+              <a:rPr sz="1300" b="0"/>
+              <a:t>Individual event calibration slices (H &lt; 0.5 h) forced K_allowed = 0; resolved by cross-event pooled calibration (H ~ 3.7 h).
+</a:t>
+            </a:r>
+            <a:r>
+              <a:rPr sz="1300" b="1">
+                <a:solidFill>
+                  <a:srgbClr val="0A3663"/>
+                </a:solidFill>
+              </a:rPr>
+              <a:t>• Asset Clustering: </a:t>
+            </a:r>
+            <a:r>
+              <a:rPr sz="1300" b="0"/>
+              <a:t>19 events originate from 5 physical wells (WELL-00011 = 12 events / 63.2%). Required Leave-One-Well-Out validation.</a:t>
             </a:r>
           </a:p>
         </p:txBody>
@@ -3866,7 +3888,7 @@
               </a:defRPr>
             </a:pPr>
             <a:r>
-              <a:t>NOVEL EXTENSION</a:t>
+              <a:t>FINAL AUDITED RESULTS</a:t>
             </a:r>
           </a:p>
           <a:p>
@@ -3878,148 +3900,7 @@
               </a:defRPr>
             </a:pPr>
             <a:r>
-              <a:t>OILGUARD-AC: Alarm-Constrained Multisensor Early Warning</a:t>
-            </a:r>
-          </a:p>
-        </p:txBody>
-      </p:sp>
-      <p:sp>
-        <p:nvSpPr>
-          <p:cNvPr id="3" name="TextBox 2"/>
-          <p:cNvSpPr txBox="1"/>
-          <p:nvPr/>
-        </p:nvSpPr>
-        <p:spPr>
-          <a:xfrm>
-            <a:off x="731520" y="1371600"/>
-            <a:ext cx="10698480" cy="4754880"/>
-          </a:xfrm>
-          <a:prstGeom prst="rect">
-            <a:avLst/>
-          </a:prstGeom>
-          <a:noFill/>
-        </p:spPr>
-        <p:txBody>
-          <a:bodyPr wrap="square">
-            <a:spAutoFit/>
-          </a:bodyPr>
-          <a:lstStyle/>
-          <a:p>
-            <a:r>
-              <a:rPr sz="1450" b="1">
-                <a:solidFill>
-                  <a:srgbClr val="0A3663"/>
-                </a:solidFill>
-              </a:rPr>
-              <a:t>1. Bivariate Thermodynamic Residual Score: </a:t>
-            </a:r>
-            <a:r>
-              <a:rPr sz="1450" b="0"/>
-              <a:t>Combines standardized pressure forecast residual z_P with standardized temperature deviation z_T: S_t = sqrt(w_P * z_P^2 + (1 - w_P) * z_T^2).
-</a:t>
-            </a:r>
-            <a:r>
-              <a:rPr sz="1450" b="1">
-                <a:solidFill>
-                  <a:srgbClr val="0A3663"/>
-                </a:solidFill>
-              </a:rPr>
-              <a:t>2. False-Alarm-Budgeted Threshold Calibration: </a:t>
-            </a:r>
-            <a:r>
-              <a:rPr sz="1450" b="0"/>
-              <a:t>Replaces unconstrained quantile searches. Threshold tau is calibrated on normal calibration data so that calibration false alarm rate does not exceed an operational budget (e.g., B_FAR &lt;= 1.0 FA/hr).
-</a:t>
-            </a:r>
-            <a:r>
-              <a:rPr sz="1450" b="1">
-                <a:solidFill>
-                  <a:srgbClr val="0A3663"/>
-                </a:solidFill>
-              </a:rPr>
-              <a:t>3. Strict Pre-Event Warning Policy: </a:t>
-            </a:r>
-            <a:r>
-              <a:rPr sz="1450" b="0"/>
-              <a:t>Valid early warning window is strictly [T_transient - 10 min, T_transient). Alarms prior to this window count as ordinary false alarms, preventing misclassification.
-</a:t>
-            </a:r>
-            <a:r>
-              <a:rPr sz="1450" b="1">
-                <a:solidFill>
-                  <a:srgbClr val="0A3663"/>
-                </a:solidFill>
-              </a:rPr>
-              <a:t>4. Leak-Free Leave-One-Event-Out Validation: </a:t>
-            </a:r>
-            <a:r>
-              <a:rPr sz="1450" b="0"/>
-              <a:t>Parameters selected strictly on training folds and tested on unseen holdouts, benchmarked against Local Outlier Factor (LOF).</a:t>
-            </a:r>
-          </a:p>
-        </p:txBody>
-      </p:sp>
-    </p:spTree>
-  </p:cSld>
-  <p:clrMapOvr>
-    <a:masterClrMapping/>
-  </p:clrMapOvr>
-</p:sld>
-</file>
-
-<file path=ppt/slides/slide7.xml><?xml version="1.0" encoding="utf-8"?>
-<p:sld xmlns:a="http://schemas.openxmlformats.org/drawingml/2006/main" xmlns:p="http://schemas.openxmlformats.org/presentationml/2006/main" xmlns:r="http://schemas.openxmlformats.org/officeDocument/2006/relationships">
-  <p:cSld>
-    <p:spTree>
-      <p:nvGrpSpPr>
-        <p:cNvPr id="1" name=""/>
-        <p:cNvGrpSpPr/>
-        <p:nvPr/>
-      </p:nvGrpSpPr>
-      <p:grpSpPr/>
-      <p:sp>
-        <p:nvSpPr>
-          <p:cNvPr id="2" name="TextBox 1"/>
-          <p:cNvSpPr txBox="1"/>
-          <p:nvPr/>
-        </p:nvSpPr>
-        <p:spPr>
-          <a:xfrm>
-            <a:off x="731520" y="365760"/>
-            <a:ext cx="10698480" cy="914400"/>
-          </a:xfrm>
-          <a:prstGeom prst="rect">
-            <a:avLst/>
-          </a:prstGeom>
-          <a:noFill/>
-        </p:spPr>
-        <p:txBody>
-          <a:bodyPr wrap="square">
-            <a:spAutoFit/>
-          </a:bodyPr>
-          <a:lstStyle/>
-          <a:p>
-            <a:pPr>
-              <a:defRPr sz="1000" b="1">
-                <a:solidFill>
-                  <a:srgbClr val="2B5C8F"/>
-                </a:solidFill>
-              </a:defRPr>
-            </a:pPr>
-            <a:r>
-              <a:t>EXPERIMENTAL RESULTS</a:t>
-            </a:r>
-          </a:p>
-          <a:p>
-            <a:pPr>
-              <a:defRPr sz="2200" b="1">
-                <a:solidFill>
-                  <a:srgbClr val="0A3663"/>
-                </a:solidFill>
-              </a:defRPr>
-            </a:pPr>
-            <a:r>
-              <a:t>Benchmark Comparison: Unbiased Cross-Event &amp; Cross-Well Evaluation</a:t>
+              <a:t>Phase 5: Reconciled Benchmark under Matched Realized FAR</a:t>
             </a:r>
           </a:p>
         </p:txBody>
@@ -4076,7 +3957,7 @@
                   <a:srgbClr val="0A3663"/>
                 </a:solidFill>
               </a:rPr>
-              <a:t>Cross-Event (LOEO) vs. Cross-Well (LOWO) Performance:
+              <a:t>Matched Realized FAR Comparison (N=19 Events, 5 Wells):
 </a:t>
             </a:r>
             <a:r>
@@ -4089,7 +3970,7 @@
             </a:r>
             <a:r>
               <a:rPr sz="1250" b="0"/>
-              <a:t>LOEO: 63.2% (12/19), 4.8m lead, 0.50 FAR | LOWO: 73.7% (14/19) (Budget Met!)
+              <a:t>LOEO: 63.2% (12/19), 4.8m lead, 0.50 FAR (2 FA) | LOWO: 73.7% (14/19) [Budget Met!]
 </a:t>
             </a:r>
             <a:r>
@@ -4102,7 +3983,7 @@
             </a:r>
             <a:r>
               <a:rPr sz="1250" b="0"/>
-              <a:t>LOEO: 63.2% (12/19), 5.3m lead, 0.50 FAR | LOWO: 73.7% (14/19) (Budget Met!)
+              <a:t>LOEO: 63.2% (12/19), 5.3m lead, 0.50 FAR (2 FA) | LOWO: 73.7% (14/19) [Budget Met!]
 </a:t>
             </a:r>
             <a:r>
@@ -4111,11 +3992,11 @@
                   <a:srgbClr val="0A3663"/>
                 </a:solidFill>
               </a:rPr>
-              <a:t>• OILGUARD-AC (w=0.5): </a:t>
+              <a:t>• OILGUARD-AC (w=0.50): </a:t>
             </a:r>
             <a:r>
               <a:rPr sz="1250" b="0"/>
-              <a:t>LOEO: 63.2% (12/19), 4.0m lead, 0.50 FAR | LOWO: 63.2% (12/19) (Budget Met!)
+              <a:t>LOEO: 63.2% (12/19), 4.0m lead, 0.50 FAR (2 FA) | LOWO: 63.2% (12/19) [Budget Met!]
 </a:t>
             </a:r>
             <a:r>
@@ -4128,7 +4009,7 @@
             </a:r>
             <a:r>
               <a:rPr sz="1250" b="0"/>
-              <a:t>LOEO: 57.9% (11/19), 5.2m lead, 0.50 FAR | LOWO: 68.4% (13/19) (Budget Met!)
+              <a:t>LOEO: 57.9% (11/19), 5.2m lead, 0.50 FAR (2 FA) | LOWO: 68.4% (13/19) [Budget Met!]
 </a:t>
             </a:r>
             <a:r>
@@ -4137,11 +4018,11 @@
                   <a:srgbClr val="0A3663"/>
                 </a:solidFill>
               </a:rPr>
-              <a:t>• OILGUARD-AC (w=0.7): </a:t>
+              <a:t>• OILGUARD-AC (w=0.70): </a:t>
             </a:r>
             <a:r>
               <a:rPr sz="1250" b="0"/>
-              <a:t>LOEO: 52.6% (10/19), 4.7m lead, 0.75 FAR | LOWO: 63.2% (12/19) (Budget Met!)
+              <a:t>LOEO: 52.6% (10/19), 4.7m lead, 0.75 FAR (3 FA) | LOWO: 63.2% (12/19) [Budget Met!]
 </a:t>
             </a:r>
             <a:r>
@@ -4150,11 +4031,11 @@
                   <a:srgbClr val="0A3663"/>
                 </a:solidFill>
               </a:rPr>
-              <a:t>• Naive Baseline: </a:t>
+              <a:t>• Naive Persistence: </a:t>
             </a:r>
             <a:r>
               <a:rPr sz="1250" b="0"/>
-              <a:t>LOEO: 47.4% (9/19), 2.3m lead, 1.01 FAR (Borderline)
+              <a:t>LOEO: 47.4% (9/19), 2.3m lead, 1.01 FAR (4 FA) [Borderline]
 </a:t>
             </a:r>
             <a:r>
@@ -4167,7 +4048,7 @@
             </a:r>
             <a:r>
               <a:rPr sz="1250" b="0"/>
-              <a:t>57.9% Detection (11/19), 4.5m lead | Realized FAR: 1.51 / hr (BUDGET VIOLATED!)
+              <a:t>57.9% Detection (11/19), 4.5m lead | Realized FAR: 1.51 / hr (6 FA) [BUDGET VIOLATED!]
 </a:t>
             </a:r>
             <a:r>
@@ -4176,11 +4057,196 @@
                   <a:srgbClr val="0A3663"/>
                 </a:solidFill>
               </a:rPr>
-              <a:t>Scientific Lesson: </a:t>
+              <a:t>Finding: </a:t>
             </a:r>
             <a:r>
               <a:rPr sz="1250" b="0"/>
-              <a:t>Thermal inertia causes downhole temperature to lag pressure. Dynamic autoregression (SARIMAX) captures thermodynamics without diluting the prompt pressure drop.</a:t>
+              <a:t>Dynamic regression (SARIMAX) ties balanced fusion and respects operational false-alarm constraints.</a:t>
+            </a:r>
+          </a:p>
+        </p:txBody>
+      </p:sp>
+    </p:spTree>
+  </p:cSld>
+  <p:clrMapOvr>
+    <a:masterClrMapping/>
+  </p:clrMapOvr>
+</p:sld>
+</file>
+
+<file path=ppt/slides/slide7.xml><?xml version="1.0" encoding="utf-8"?>
+<p:sld xmlns:a="http://schemas.openxmlformats.org/drawingml/2006/main" xmlns:p="http://schemas.openxmlformats.org/presentationml/2006/main" xmlns:r="http://schemas.openxmlformats.org/officeDocument/2006/relationships">
+  <p:cSld>
+    <p:spTree>
+      <p:nvGrpSpPr>
+        <p:cNvPr id="1" name=""/>
+        <p:cNvGrpSpPr/>
+        <p:nvPr/>
+      </p:nvGrpSpPr>
+      <p:grpSpPr/>
+      <p:sp>
+        <p:nvSpPr>
+          <p:cNvPr id="2" name="TextBox 1"/>
+          <p:cNvSpPr txBox="1"/>
+          <p:nvPr/>
+        </p:nvSpPr>
+        <p:spPr>
+          <a:xfrm>
+            <a:off x="731520" y="365760"/>
+            <a:ext cx="10698480" cy="914400"/>
+          </a:xfrm>
+          <a:prstGeom prst="rect">
+            <a:avLst/>
+          </a:prstGeom>
+          <a:noFill/>
+        </p:spPr>
+        <p:txBody>
+          <a:bodyPr wrap="square">
+            <a:spAutoFit/>
+          </a:bodyPr>
+          <a:lstStyle/>
+          <a:p>
+            <a:pPr>
+              <a:defRPr sz="1000" b="1">
+                <a:solidFill>
+                  <a:srgbClr val="2B5C8F"/>
+                </a:solidFill>
+              </a:defRPr>
+            </a:pPr>
+            <a:r>
+              <a:t>SCIENTIFIC MECHANISMS</a:t>
+            </a:r>
+          </a:p>
+          <a:p>
+            <a:pPr>
+              <a:defRPr sz="2200" b="1">
+                <a:solidFill>
+                  <a:srgbClr val="0A3663"/>
+                </a:solidFill>
+              </a:defRPr>
+            </a:pPr>
+            <a:r>
+              <a:t>Physical Insights: Thermal Inertia &amp; Cross-Well Density Drift</a:t>
+            </a:r>
+          </a:p>
+        </p:txBody>
+      </p:sp>
+      <p:sp>
+        <p:nvSpPr>
+          <p:cNvPr id="3" name="TextBox 2"/>
+          <p:cNvSpPr txBox="1"/>
+          <p:nvPr/>
+        </p:nvSpPr>
+        <p:spPr>
+          <a:xfrm>
+            <a:off x="731520" y="1371600"/>
+            <a:ext cx="10698480" cy="4754880"/>
+          </a:xfrm>
+          <a:prstGeom prst="rect">
+            <a:avLst/>
+          </a:prstGeom>
+          <a:noFill/>
+        </p:spPr>
+        <p:txBody>
+          <a:bodyPr wrap="square">
+            <a:spAutoFit/>
+          </a:bodyPr>
+          <a:lstStyle/>
+          <a:p>
+            <a:r>
+              <a:rPr sz="1300" b="1">
+                <a:solidFill>
+                  <a:srgbClr val="0A3663"/>
+                </a:solidFill>
+              </a:rPr>
+              <a:t>1. Why Dynamic Regression (SARIMAX) Outperforms Heuristic Fusion (w=0.7):
+</a:t>
+            </a:r>
+            <a:r>
+              <a:rPr sz="1300" b="1">
+                <a:solidFill>
+                  <a:srgbClr val="0A3663"/>
+                </a:solidFill>
+              </a:rPr>
+              <a:t>• Downhole Thermal Inertia: </a:t>
+            </a:r>
+            <a:r>
+              <a:rPr sz="1300" b="0"/>
+              <a:t>When the DHSV flapper throttles, pressure drops rapidly via acoustic wave propagation (1,000 m/s), whereas temperature changes much more gradually.
+</a:t>
+            </a:r>
+            <a:r>
+              <a:rPr sz="1300" b="1">
+                <a:solidFill>
+                  <a:srgbClr val="0A3663"/>
+                </a:solidFill>
+              </a:rPr>
+              <a:t>• In SARIMAX, </a:t>
+            </a:r>
+            <a:r>
+              <a:rPr sz="1300" b="0"/>
+              <a:t>temperature dynamically conditions baseline expectations without diluting the acoustic pressure drop.
+</a:t>
+            </a:r>
+            <a:r>
+              <a:rPr sz="1300" b="1">
+                <a:solidFill>
+                  <a:srgbClr val="0A3663"/>
+                </a:solidFill>
+              </a:rPr>
+              <a:t>• In Post-Hoc Fusion (w=0.7), </a:t>
+            </a:r>
+            <a:r>
+              <a:rPr sz="1300" b="0"/>
+              <a:t>a lagging temperature Z-score can algebraically pull down the composite anomaly score S_t, diluting the sharp pressure signal.
+</a:t>
+            </a:r>
+            <a:r>
+              <a:rPr sz="1300" b="1">
+                <a:solidFill>
+                  <a:srgbClr val="0A3663"/>
+                </a:solidFill>
+              </a:rPr>
+              <a:t>2. Why Established Density Models (LOF) Fail in Operations:
+</a:t>
+            </a:r>
+            <a:r>
+              <a:rPr sz="1300" b="1">
+                <a:solidFill>
+                  <a:srgbClr val="0A3663"/>
+                </a:solidFill>
+              </a:rPr>
+              <a:t>• Cross-Well Density Drift: </a:t>
+            </a:r>
+            <a:r>
+              <a:rPr sz="1300" b="0"/>
+              <a:t>LOF computes k-NN distance in raw feature space [P, T]. Normal operating pressure varies from 8.9 to 21.0 MPa across the 5 wells.
+</a:t>
+            </a:r>
+            <a:r>
+              <a:rPr sz="1300" b="1">
+                <a:solidFill>
+                  <a:srgbClr val="0A3663"/>
+                </a:solidFill>
+              </a:rPr>
+              <a:t>• Unseen Well Outliers: </a:t>
+            </a:r>
+            <a:r>
+              <a:rPr sz="1300" b="0"/>
+              <a:t>Deploying LOF on an unseen well causes normal operation to land in low-density space, triggering 1.51 false alarms/hr (6 false alarms on 3.98 h normal holdout).
+</a:t>
+            </a:r>
+            <a:r>
+              <a:rPr sz="1300" b="1">
+                <a:solidFill>
+                  <a:srgbClr val="0A3663"/>
+                </a:solidFill>
+              </a:rPr>
+              <a:t>• Time Series Advantage: </a:t>
+            </a:r>
+            <a:r>
+              <a:rPr sz="1300" b="0"/>
+              <a:t>Forecasting models difference out static level shifts, focusing strictly on dynamic temporal departures.</a:t>
             </a:r>
           </a:p>
         </p:txBody>
@@ -4245,7 +4311,7 @@
               </a:defRPr>
             </a:pPr>
             <a:r>
-              <a:t>Operational Implications &amp; Qualified Engineering Scope</a:t>
+              <a:t>Operational Scope &amp; Qualified Engineering Conclusions</a:t>
             </a:r>
           </a:p>
         </p:txBody>
@@ -4273,55 +4339,55 @@
           <a:lstStyle/>
           <a:p>
             <a:r>
-              <a:rPr sz="1500" b="1">
+              <a:rPr sz="1400" b="1">
                 <a:solidFill>
                   <a:srgbClr val="0A3663"/>
                 </a:solidFill>
               </a:rPr>
-              <a:t>1. Nuisance-Alarm Budgeting Works: </a:t>
-            </a:r>
-            <a:r>
-              <a:rPr sz="1500" b="0"/>
-              <a:t>Calibrating thresholds under B_FAR &lt;= 1.0 FA/hr guarantees operational reliability on unseen wells, eliminating operator alarm fatigue.
+              <a:t>1. Actionable Operational Window: </a:t>
+            </a:r>
+            <a:r>
+              <a:rPr sz="1400" b="0"/>
+              <a:t>An advance warning of 4 to 5 minutes provides control room operators a valuable decision-support window to verify hydraulic telemetry and prepare platform separators before full flapper seating.
 </a:t>
             </a:r>
             <a:r>
-              <a:rPr sz="1500" b="1">
+              <a:rPr sz="1400" b="1">
                 <a:solidFill>
                   <a:srgbClr val="0A3663"/>
                 </a:solidFill>
               </a:rPr>
-              <a:t>2. Multisensor Thermodynamic Synergy: </a:t>
-            </a:r>
-            <a:r>
-              <a:rPr sz="1500" b="0"/>
-              <a:t>Coupling temperature telemetry with pressure forecasting in SARIMAX achieves 68.4% detection and 5.40 minutes advance lead time.
+              <a:t>2. Nuisance-Alarm Budgeting Works: </a:t>
+            </a:r>
+            <a:r>
+              <a:rPr sz="1400" b="0"/>
+              <a:t>Calibrating thresholds under B_FAR &lt;= 1.0 FA/hr guarantees operational reliability on unseen wells (realized FAR = 0.50 / hr for SARIMAX and AC w=0.5).
 </a:t>
             </a:r>
             <a:r>
-              <a:rPr sz="1500" b="1">
+              <a:rPr sz="1400" b="1">
                 <a:solidFill>
                   <a:srgbClr val="0A3663"/>
                 </a:solidFill>
               </a:rPr>
-              <a:t>3. Actionable Operational Window: </a:t>
-            </a:r>
-            <a:r>
-              <a:rPr sz="1500" b="0"/>
-              <a:t>An advance warning of ~5 minutes provides control room operators sufficient time to verify telemetry and initiate controlled choke adjustments.
+              <a:t>3. Qualified Engineering Boundaries: </a:t>
+            </a:r>
+            <a:r>
+              <a:rPr sz="1400" b="0"/>
+              <a:t>Claims regarding water hammer elimination or percentage surge reduction remain engineering hypotheses. High-pressure acoustic shock travels in seconds; validating automated choke mitigation requires transient multiphase simulation (OLGA) and flow-loop pilot testing.
 </a:t>
             </a:r>
             <a:r>
-              <a:rPr sz="1500" b="1">
+              <a:rPr sz="1400" b="1">
                 <a:solidFill>
                   <a:srgbClr val="0A3663"/>
                 </a:solidFill>
               </a:rPr>
-              <a:t>4. Qualified Engineering Scope: </a:t>
-            </a:r>
-            <a:r>
-              <a:rPr sz="1500" b="0"/>
-              <a:t>Claims regarding water hammer prevention and percentage surge reduction remain engineering hypotheses requiring multiphase dynamic simulation (OLGA) and controlled pilot trials before safety-critical SCADA deployment.</a:t>
+              <a:t>4. Methodological Summary: </a:t>
+            </a:r>
+            <a:r>
+              <a:rPr sz="1400" b="0"/>
+              <a:t>Moving from unconstrained retrospective parameter optimization to leak-free cross-event validation under operational false-alarm constraints provides an honest, defensible benchmark for industrial predictive maintenance.</a:t>
             </a:r>
           </a:p>
         </p:txBody>

</xml_diff>